<commit_message>
adding image fixtures and integration tests
</commit_message>
<xml_diff>
--- a/tests/fixtures/integration/pptx/basic.pptx
+++ b/tests/fixtures/integration/pptx/basic.pptx
@@ -5,7 +5,7 @@
     <p:sldMasterId id="2147483648" r:id="rId1"/>
   </p:sldMasterIdLst>
   <p:notesMasterIdLst>
-    <p:notesMasterId r:id="rId8"/>
+    <p:notesMasterId r:id="rId9"/>
   </p:notesMasterIdLst>
   <p:sldIdLst>
     <p:sldId id="257" r:id="rId2"/>
@@ -14,6 +14,7 @@
     <p:sldId id="260" r:id="rId5"/>
     <p:sldId id="261" r:id="rId6"/>
     <p:sldId id="262" r:id="rId7"/>
+    <p:sldId id="264" r:id="rId8"/>
   </p:sldIdLst>
   <p:sldSz cx="12192000" cy="6858000"/>
   <p:notesSz cx="6858000" cy="9144000"/>
@@ -229,7 +230,7 @@
           <a:p>
             <a:fld id="{A33BA8A1-DF13-4BD8-B76C-CD685F1F205F}" type="datetimeFigureOut">
               <a:rPr lang="de-DE" smtClean="0"/>
-              <a:t>13.07.2026</a:t>
+              <a:t>14.07.2026</a:t>
             </a:fld>
             <a:endParaRPr lang="de-DE"/>
           </a:p>
@@ -776,7 +777,7 @@
           <a:p>
             <a:fld id="{3212E68A-3362-4143-9501-ACA13EC97928}" type="datetimeFigureOut">
               <a:rPr lang="de-DE" smtClean="0"/>
-              <a:t>13.07.2026</a:t>
+              <a:t>14.07.2026</a:t>
             </a:fld>
             <a:endParaRPr lang="de-DE"/>
           </a:p>
@@ -974,7 +975,7 @@
           <a:p>
             <a:fld id="{3212E68A-3362-4143-9501-ACA13EC97928}" type="datetimeFigureOut">
               <a:rPr lang="de-DE" smtClean="0"/>
-              <a:t>13.07.2026</a:t>
+              <a:t>14.07.2026</a:t>
             </a:fld>
             <a:endParaRPr lang="de-DE"/>
           </a:p>
@@ -1182,7 +1183,7 @@
           <a:p>
             <a:fld id="{3212E68A-3362-4143-9501-ACA13EC97928}" type="datetimeFigureOut">
               <a:rPr lang="de-DE" smtClean="0"/>
-              <a:t>13.07.2026</a:t>
+              <a:t>14.07.2026</a:t>
             </a:fld>
             <a:endParaRPr lang="de-DE"/>
           </a:p>
@@ -1380,7 +1381,7 @@
           <a:p>
             <a:fld id="{3212E68A-3362-4143-9501-ACA13EC97928}" type="datetimeFigureOut">
               <a:rPr lang="de-DE" smtClean="0"/>
-              <a:t>13.07.2026</a:t>
+              <a:t>14.07.2026</a:t>
             </a:fld>
             <a:endParaRPr lang="de-DE"/>
           </a:p>
@@ -1655,7 +1656,7 @@
           <a:p>
             <a:fld id="{3212E68A-3362-4143-9501-ACA13EC97928}" type="datetimeFigureOut">
               <a:rPr lang="de-DE" smtClean="0"/>
-              <a:t>13.07.2026</a:t>
+              <a:t>14.07.2026</a:t>
             </a:fld>
             <a:endParaRPr lang="de-DE"/>
           </a:p>
@@ -1920,7 +1921,7 @@
           <a:p>
             <a:fld id="{3212E68A-3362-4143-9501-ACA13EC97928}" type="datetimeFigureOut">
               <a:rPr lang="de-DE" smtClean="0"/>
-              <a:t>13.07.2026</a:t>
+              <a:t>14.07.2026</a:t>
             </a:fld>
             <a:endParaRPr lang="de-DE"/>
           </a:p>
@@ -2332,7 +2333,7 @@
           <a:p>
             <a:fld id="{3212E68A-3362-4143-9501-ACA13EC97928}" type="datetimeFigureOut">
               <a:rPr lang="de-DE" smtClean="0"/>
-              <a:t>13.07.2026</a:t>
+              <a:t>14.07.2026</a:t>
             </a:fld>
             <a:endParaRPr lang="de-DE"/>
           </a:p>
@@ -2473,7 +2474,7 @@
           <a:p>
             <a:fld id="{3212E68A-3362-4143-9501-ACA13EC97928}" type="datetimeFigureOut">
               <a:rPr lang="de-DE" smtClean="0"/>
-              <a:t>13.07.2026</a:t>
+              <a:t>14.07.2026</a:t>
             </a:fld>
             <a:endParaRPr lang="de-DE"/>
           </a:p>
@@ -2586,7 +2587,7 @@
           <a:p>
             <a:fld id="{3212E68A-3362-4143-9501-ACA13EC97928}" type="datetimeFigureOut">
               <a:rPr lang="de-DE" smtClean="0"/>
-              <a:t>13.07.2026</a:t>
+              <a:t>14.07.2026</a:t>
             </a:fld>
             <a:endParaRPr lang="de-DE"/>
           </a:p>
@@ -2897,7 +2898,7 @@
           <a:p>
             <a:fld id="{3212E68A-3362-4143-9501-ACA13EC97928}" type="datetimeFigureOut">
               <a:rPr lang="de-DE" smtClean="0"/>
-              <a:t>13.07.2026</a:t>
+              <a:t>14.07.2026</a:t>
             </a:fld>
             <a:endParaRPr lang="de-DE"/>
           </a:p>
@@ -3185,7 +3186,7 @@
           <a:p>
             <a:fld id="{3212E68A-3362-4143-9501-ACA13EC97928}" type="datetimeFigureOut">
               <a:rPr lang="de-DE" smtClean="0"/>
-              <a:t>13.07.2026</a:t>
+              <a:t>14.07.2026</a:t>
             </a:fld>
             <a:endParaRPr lang="de-DE"/>
           </a:p>
@@ -3426,7 +3427,7 @@
           <a:p>
             <a:fld id="{3212E68A-3362-4143-9501-ACA13EC97928}" type="datetimeFigureOut">
               <a:rPr lang="de-DE" smtClean="0"/>
-              <a:t>13.07.2026</a:t>
+              <a:t>14.07.2026</a:t>
             </a:fld>
             <a:endParaRPr lang="de-DE"/>
           </a:p>
@@ -4969,6 +4970,640 @@
       <p188:commentRel xmlns:p188="http://schemas.microsoft.com/office/powerpoint/2018/8/main" r:id="rId3"/>
     </p:ext>
   </p:extLst>
+</p:sld>
+</file>
+
+<file path=ppt/slides/slide7.xml><?xml version="1.0" encoding="utf-8"?>
+<p:sld xmlns:a="http://schemas.openxmlformats.org/drawingml/2006/main" xmlns:r="http://schemas.openxmlformats.org/officeDocument/2006/relationships" xmlns:p="http://schemas.openxmlformats.org/presentationml/2006/main">
+  <p:cSld>
+    <p:bg>
+      <p:bgPr>
+        <a:solidFill>
+          <a:schemeClr val="bg1"/>
+        </a:solidFill>
+        <a:effectLst/>
+      </p:bgPr>
+    </p:bg>
+    <p:spTree>
+      <p:nvGrpSpPr>
+        <p:cNvPr id="1" name=""/>
+        <p:cNvGrpSpPr/>
+        <p:nvPr/>
+      </p:nvGrpSpPr>
+      <p:grpSpPr>
+        <a:xfrm>
+          <a:off x="0" y="0"/>
+          <a:ext cx="0" cy="0"/>
+          <a:chOff x="0" y="0"/>
+          <a:chExt cx="0" cy="0"/>
+        </a:xfrm>
+      </p:grpSpPr>
+      <p:sp useBgFill="1">
+        <p:nvSpPr>
+          <p:cNvPr id="9" name="Rectangle 8">
+            <a:extLst>
+              <a:ext uri="{FF2B5EF4-FFF2-40B4-BE49-F238E27FC236}">
+                <a16:creationId xmlns:a16="http://schemas.microsoft.com/office/drawing/2014/main" id="{06DA9DF9-31F7-4056-B42E-878CC92417B8}"/>
+              </a:ext>
+              <a:ext uri="{C183D7F6-B498-43B3-948B-1728B52AA6E4}">
+                <adec:decorative xmlns:adec="http://schemas.microsoft.com/office/drawing/2017/decorative" val="1"/>
+              </a:ext>
+            </a:extLst>
+          </p:cNvPr>
+          <p:cNvSpPr>
+            <a:spLocks noGrp="1" noRot="1" noChangeAspect="1" noMove="1" noResize="1" noEditPoints="1" noAdjustHandles="1" noChangeArrowheads="1" noChangeShapeType="1" noTextEdit="1"/>
+          </p:cNvSpPr>
+          <p:nvPr>
+            <p:extLst>
+              <p:ext uri="{386F3935-93C4-4BCD-93E2-E3B085C9AB24}">
+                <p16:designElem xmlns:p16="http://schemas.microsoft.com/office/powerpoint/2015/main" val="1"/>
+              </p:ext>
+            </p:extLst>
+          </p:nvPr>
+        </p:nvSpPr>
+        <p:spPr>
+          <a:xfrm>
+            <a:off x="0" y="0"/>
+            <a:ext cx="12188952" cy="6858000"/>
+          </a:xfrm>
+          <a:prstGeom prst="rect">
+            <a:avLst/>
+          </a:prstGeom>
+          <a:ln>
+            <a:noFill/>
+          </a:ln>
+        </p:spPr>
+        <p:style>
+          <a:lnRef idx="2">
+            <a:schemeClr val="accent1">
+              <a:shade val="50000"/>
+            </a:schemeClr>
+          </a:lnRef>
+          <a:fillRef idx="1">
+            <a:schemeClr val="accent1"/>
+          </a:fillRef>
+          <a:effectRef idx="0">
+            <a:schemeClr val="accent1"/>
+          </a:effectRef>
+          <a:fontRef idx="minor">
+            <a:schemeClr val="lt1"/>
+          </a:fontRef>
+        </p:style>
+        <p:txBody>
+          <a:bodyPr rtlCol="0" anchor="ctr"/>
+          <a:lstStyle/>
+          <a:p>
+            <a:pPr algn="ctr"/>
+            <a:endParaRPr lang="en-US"/>
+          </a:p>
+        </p:txBody>
+      </p:sp>
+      <p:sp>
+        <p:nvSpPr>
+          <p:cNvPr id="2" name="Titel 1">
+            <a:extLst>
+              <a:ext uri="{FF2B5EF4-FFF2-40B4-BE49-F238E27FC236}">
+                <a16:creationId xmlns:a16="http://schemas.microsoft.com/office/drawing/2014/main" id="{E0340BC9-99C6-15F7-EF80-7D994E78B0B0}"/>
+              </a:ext>
+            </a:extLst>
+          </p:cNvPr>
+          <p:cNvSpPr>
+            <a:spLocks noGrp="1"/>
+          </p:cNvSpPr>
+          <p:nvPr>
+            <p:ph type="title"/>
+          </p:nvPr>
+        </p:nvSpPr>
+        <p:spPr>
+          <a:xfrm>
+            <a:off x="643468" y="643467"/>
+            <a:ext cx="4620584" cy="4567137"/>
+          </a:xfrm>
+        </p:spPr>
+        <p:txBody>
+          <a:bodyPr vert="horz" lIns="91440" tIns="45720" rIns="91440" bIns="45720" rtlCol="0" anchor="b">
+            <a:normAutofit/>
+          </a:bodyPr>
+          <a:lstStyle/>
+          <a:p>
+            <a:r>
+              <a:rPr lang="en-US"/>
+              <a:t>Image</a:t>
+            </a:r>
+          </a:p>
+        </p:txBody>
+      </p:sp>
+      <p:pic>
+        <p:nvPicPr>
+          <p:cNvPr id="4" name="Grafik 3">
+            <a:extLst>
+              <a:ext uri="{FF2B5EF4-FFF2-40B4-BE49-F238E27FC236}">
+                <a16:creationId xmlns:a16="http://schemas.microsoft.com/office/drawing/2014/main" id="{74B856DB-9B3D-21A7-B81C-929CD8B3993B}"/>
+              </a:ext>
+            </a:extLst>
+          </p:cNvPr>
+          <p:cNvPicPr>
+            <a:picLocks noChangeAspect="1"/>
+          </p:cNvPicPr>
+          <p:nvPr/>
+        </p:nvPicPr>
+        <p:blipFill>
+          <a:blip r:embed="rId2">
+            <a:extLst>
+              <a:ext uri="{28A0092B-C50C-407E-A947-70E740481C1C}">
+                <a14:useLocalDpi xmlns:a14="http://schemas.microsoft.com/office/drawing/2010/main" val="0"/>
+              </a:ext>
+            </a:extLst>
+          </a:blip>
+          <a:srcRect t="3568" r="-3" b="5857"/>
+          <a:stretch>
+            <a:fillRect/>
+          </a:stretch>
+        </p:blipFill>
+        <p:spPr>
+          <a:xfrm>
+            <a:off x="6229215" y="10"/>
+            <a:ext cx="5962785" cy="6857990"/>
+          </a:xfrm>
+          <a:custGeom>
+            <a:avLst/>
+            <a:gdLst/>
+            <a:ahLst/>
+            <a:cxnLst/>
+            <a:rect l="l" t="t" r="r" b="b"/>
+            <a:pathLst>
+              <a:path w="5962785" h="6858000">
+                <a:moveTo>
+                  <a:pt x="1044839" y="0"/>
+                </a:moveTo>
+                <a:lnTo>
+                  <a:pt x="5962785" y="0"/>
+                </a:lnTo>
+                <a:lnTo>
+                  <a:pt x="5962785" y="6858000"/>
+                </a:lnTo>
+                <a:lnTo>
+                  <a:pt x="1469886" y="6858000"/>
+                </a:lnTo>
+                <a:lnTo>
+                  <a:pt x="1416006" y="6823984"/>
+                </a:lnTo>
+                <a:cubicBezTo>
+                  <a:pt x="1356767" y="6787940"/>
+                  <a:pt x="1296437" y="6755500"/>
+                  <a:pt x="1232473" y="6733873"/>
+                </a:cubicBezTo>
+                <a:cubicBezTo>
+                  <a:pt x="1145250" y="6705037"/>
+                  <a:pt x="1060933" y="6654575"/>
+                  <a:pt x="1075471" y="6503186"/>
+                </a:cubicBezTo>
+                <a:cubicBezTo>
+                  <a:pt x="1078378" y="6459932"/>
+                  <a:pt x="1055118" y="6427493"/>
+                  <a:pt x="1020229" y="6438306"/>
+                </a:cubicBezTo>
+                <a:cubicBezTo>
+                  <a:pt x="953358" y="6459932"/>
+                  <a:pt x="921375" y="6398656"/>
+                  <a:pt x="883579" y="6351798"/>
+                </a:cubicBezTo>
+                <a:cubicBezTo>
+                  <a:pt x="816707" y="6268895"/>
+                  <a:pt x="752743" y="6182387"/>
+                  <a:pt x="645167" y="6167969"/>
+                </a:cubicBezTo>
+                <a:cubicBezTo>
+                  <a:pt x="665519" y="6103088"/>
+                  <a:pt x="700408" y="6110298"/>
+                  <a:pt x="732391" y="6124716"/>
+                </a:cubicBezTo>
+                <a:cubicBezTo>
+                  <a:pt x="816707" y="6160761"/>
+                  <a:pt x="901023" y="6200410"/>
+                  <a:pt x="985339" y="6236455"/>
+                </a:cubicBezTo>
+                <a:cubicBezTo>
+                  <a:pt x="1040581" y="6258081"/>
+                  <a:pt x="1095822" y="6290522"/>
+                  <a:pt x="1168509" y="6265291"/>
+                </a:cubicBezTo>
+                <a:cubicBezTo>
+                  <a:pt x="1104545" y="6135530"/>
+                  <a:pt x="996969" y="6110298"/>
+                  <a:pt x="909746" y="6070649"/>
+                </a:cubicBezTo>
+                <a:cubicBezTo>
+                  <a:pt x="802169" y="6020185"/>
+                  <a:pt x="738206" y="5926470"/>
+                  <a:pt x="659704" y="5818335"/>
+                </a:cubicBezTo>
+                <a:cubicBezTo>
+                  <a:pt x="738206" y="5789500"/>
+                  <a:pt x="787632" y="5868798"/>
+                  <a:pt x="851597" y="5865193"/>
+                </a:cubicBezTo>
+                <a:cubicBezTo>
+                  <a:pt x="854504" y="5854380"/>
+                  <a:pt x="860319" y="5832753"/>
+                  <a:pt x="860319" y="5832753"/>
+                </a:cubicBezTo>
+                <a:cubicBezTo>
+                  <a:pt x="755650" y="5775081"/>
+                  <a:pt x="709132" y="5666947"/>
+                  <a:pt x="691686" y="5533581"/>
+                </a:cubicBezTo>
+                <a:cubicBezTo>
+                  <a:pt x="685872" y="5465095"/>
+                  <a:pt x="648075" y="5443468"/>
+                  <a:pt x="610278" y="5411029"/>
+                </a:cubicBezTo>
+                <a:cubicBezTo>
+                  <a:pt x="482350" y="5299289"/>
+                  <a:pt x="345700" y="5198364"/>
+                  <a:pt x="238123" y="5046976"/>
+                </a:cubicBezTo>
+                <a:cubicBezTo>
+                  <a:pt x="363144" y="5064998"/>
+                  <a:pt x="461997" y="5165924"/>
+                  <a:pt x="592833" y="5209177"/>
+                </a:cubicBezTo>
+                <a:cubicBezTo>
+                  <a:pt x="488165" y="5043371"/>
+                  <a:pt x="351514" y="4956864"/>
+                  <a:pt x="226494" y="4855939"/>
+                </a:cubicBezTo>
+                <a:cubicBezTo>
+                  <a:pt x="168344" y="4809081"/>
+                  <a:pt x="116011" y="4751408"/>
+                  <a:pt x="49139" y="4726177"/>
+                </a:cubicBezTo>
+                <a:cubicBezTo>
+                  <a:pt x="25879" y="4718968"/>
+                  <a:pt x="-14825" y="4700947"/>
+                  <a:pt x="5527" y="4650483"/>
+                </a:cubicBezTo>
+                <a:cubicBezTo>
+                  <a:pt x="22972" y="4607230"/>
+                  <a:pt x="54954" y="4621648"/>
+                  <a:pt x="84029" y="4632460"/>
+                </a:cubicBezTo>
+                <a:cubicBezTo>
+                  <a:pt x="153807" y="4661296"/>
+                  <a:pt x="229401" y="4661296"/>
+                  <a:pt x="325347" y="4661296"/>
+                </a:cubicBezTo>
+                <a:cubicBezTo>
+                  <a:pt x="243939" y="4524326"/>
+                  <a:pt x="95658" y="4567580"/>
+                  <a:pt x="25879" y="4423401"/>
+                </a:cubicBezTo>
+                <a:cubicBezTo>
+                  <a:pt x="113103" y="4398170"/>
+                  <a:pt x="179975" y="4448632"/>
+                  <a:pt x="249753" y="4459446"/>
+                </a:cubicBezTo>
+                <a:cubicBezTo>
+                  <a:pt x="313718" y="4470259"/>
+                  <a:pt x="328254" y="4445028"/>
+                  <a:pt x="313718" y="4365729"/>
+                </a:cubicBezTo>
+                <a:cubicBezTo>
+                  <a:pt x="290458" y="4243177"/>
+                  <a:pt x="325347" y="4181900"/>
+                  <a:pt x="418386" y="4214341"/>
+                </a:cubicBezTo>
+                <a:cubicBezTo>
+                  <a:pt x="505609" y="4246781"/>
+                  <a:pt x="514332" y="4199922"/>
+                  <a:pt x="491072" y="4131438"/>
+                </a:cubicBezTo>
+                <a:cubicBezTo>
+                  <a:pt x="456183" y="4030512"/>
+                  <a:pt x="493979" y="3951214"/>
+                  <a:pt x="520147" y="3864706"/>
+                </a:cubicBezTo>
+                <a:cubicBezTo>
+                  <a:pt x="560851" y="3734945"/>
+                  <a:pt x="543407" y="3670064"/>
+                  <a:pt x="459090" y="3572743"/>
+                </a:cubicBezTo>
+                <a:cubicBezTo>
+                  <a:pt x="409664" y="3518676"/>
+                  <a:pt x="360236" y="3471818"/>
+                  <a:pt x="290458" y="3424959"/>
+                </a:cubicBezTo>
+                <a:cubicBezTo>
+                  <a:pt x="450368" y="3399728"/>
+                  <a:pt x="284643" y="3313221"/>
+                  <a:pt x="339884" y="3259153"/>
+                </a:cubicBezTo>
+                <a:cubicBezTo>
+                  <a:pt x="453275" y="3237527"/>
+                  <a:pt x="543407" y="3410542"/>
+                  <a:pt x="697501" y="3360078"/>
+                </a:cubicBezTo>
+                <a:cubicBezTo>
+                  <a:pt x="511425" y="3212294"/>
+                  <a:pt x="302087" y="3165436"/>
+                  <a:pt x="165437" y="2967190"/>
+                </a:cubicBezTo>
+                <a:cubicBezTo>
+                  <a:pt x="197419" y="2923937"/>
+                  <a:pt x="229401" y="2967190"/>
+                  <a:pt x="255568" y="2949167"/>
+                </a:cubicBezTo>
+                <a:cubicBezTo>
+                  <a:pt x="255568" y="2938354"/>
+                  <a:pt x="560851" y="3006840"/>
+                  <a:pt x="578296" y="2725691"/>
+                </a:cubicBezTo>
+                <a:cubicBezTo>
+                  <a:pt x="584111" y="2725691"/>
+                  <a:pt x="589926" y="2725691"/>
+                  <a:pt x="595740" y="2714876"/>
+                </a:cubicBezTo>
+                <a:cubicBezTo>
+                  <a:pt x="627722" y="2675228"/>
+                  <a:pt x="598648" y="2581510"/>
+                  <a:pt x="650982" y="2574301"/>
+                </a:cubicBezTo>
+                <a:cubicBezTo>
+                  <a:pt x="709132" y="2567092"/>
+                  <a:pt x="764373" y="2534653"/>
+                  <a:pt x="825429" y="2552674"/>
+                </a:cubicBezTo>
+                <a:cubicBezTo>
+                  <a:pt x="871949" y="2567092"/>
+                  <a:pt x="921375" y="2585115"/>
+                  <a:pt x="970802" y="2585115"/>
+                </a:cubicBezTo>
+                <a:cubicBezTo>
+                  <a:pt x="1023136" y="2585115"/>
+                  <a:pt x="1095822" y="2707668"/>
+                  <a:pt x="1127805" y="2545465"/>
+                </a:cubicBezTo>
+                <a:cubicBezTo>
+                  <a:pt x="1127805" y="2538257"/>
+                  <a:pt x="1217936" y="2556280"/>
+                  <a:pt x="1267362" y="2563488"/>
+                </a:cubicBezTo>
+                <a:cubicBezTo>
+                  <a:pt x="1308067" y="2570698"/>
+                  <a:pt x="1357494" y="2603137"/>
+                  <a:pt x="1386568" y="2538257"/>
+                </a:cubicBezTo>
+                <a:cubicBezTo>
+                  <a:pt x="1401105" y="2498607"/>
+                  <a:pt x="1331326" y="2426518"/>
+                  <a:pt x="1270270" y="2419309"/>
+                </a:cubicBezTo>
+                <a:cubicBezTo>
+                  <a:pt x="1215029" y="2412101"/>
+                  <a:pt x="1159787" y="2404892"/>
+                  <a:pt x="1107453" y="2419309"/>
+                </a:cubicBezTo>
+                <a:cubicBezTo>
+                  <a:pt x="1043489" y="2437331"/>
+                  <a:pt x="1008599" y="2408495"/>
+                  <a:pt x="991154" y="2343615"/>
+                </a:cubicBezTo>
+                <a:cubicBezTo>
+                  <a:pt x="970802" y="2275131"/>
+                  <a:pt x="933005" y="2239085"/>
+                  <a:pt x="880671" y="2206645"/>
+                </a:cubicBezTo>
+                <a:cubicBezTo>
+                  <a:pt x="752743" y="2127346"/>
+                  <a:pt x="630630" y="2033629"/>
+                  <a:pt x="491072" y="1986771"/>
+                </a:cubicBezTo>
+                <a:cubicBezTo>
+                  <a:pt x="464905" y="1979562"/>
+                  <a:pt x="432923" y="1965145"/>
+                  <a:pt x="421293" y="1903868"/>
+                </a:cubicBezTo>
+                <a:cubicBezTo>
+                  <a:pt x="799262" y="1997584"/>
+                  <a:pt x="1142342" y="2239085"/>
+                  <a:pt x="1531941" y="2224667"/>
+                </a:cubicBezTo>
+                <a:cubicBezTo>
+                  <a:pt x="1427272" y="2148974"/>
+                  <a:pt x="1302252" y="2145369"/>
+                  <a:pt x="1188861" y="2091301"/>
+                </a:cubicBezTo>
+                <a:cubicBezTo>
+                  <a:pt x="1270270" y="2051652"/>
+                  <a:pt x="1345864" y="2094906"/>
+                  <a:pt x="1421458" y="2116532"/>
+                </a:cubicBezTo>
+                <a:cubicBezTo>
+                  <a:pt x="1485422" y="2134554"/>
+                  <a:pt x="1543571" y="2138160"/>
+                  <a:pt x="1549386" y="2026420"/>
+                </a:cubicBezTo>
+                <a:cubicBezTo>
+                  <a:pt x="1549386" y="2015607"/>
+                  <a:pt x="1549386" y="2008398"/>
+                  <a:pt x="1549386" y="1997584"/>
+                </a:cubicBezTo>
+                <a:cubicBezTo>
+                  <a:pt x="1526126" y="1950727"/>
+                  <a:pt x="1494144" y="1929099"/>
+                  <a:pt x="1453440" y="1914682"/>
+                </a:cubicBezTo>
+                <a:cubicBezTo>
+                  <a:pt x="1430180" y="1907473"/>
+                  <a:pt x="1398198" y="1893056"/>
+                  <a:pt x="1398198" y="1860614"/>
+                </a:cubicBezTo>
+                <a:cubicBezTo>
+                  <a:pt x="1401105" y="1738063"/>
+                  <a:pt x="1322604" y="1702018"/>
+                  <a:pt x="1247011" y="1665972"/>
+                </a:cubicBezTo>
+                <a:cubicBezTo>
+                  <a:pt x="1287715" y="1604696"/>
+                  <a:pt x="1322604" y="1647950"/>
+                  <a:pt x="1354586" y="1644345"/>
+                </a:cubicBezTo>
+                <a:cubicBezTo>
+                  <a:pt x="1374939" y="1640741"/>
+                  <a:pt x="1395290" y="1637138"/>
+                  <a:pt x="1395290" y="1604696"/>
+                </a:cubicBezTo>
+                <a:cubicBezTo>
+                  <a:pt x="1395290" y="1579465"/>
+                  <a:pt x="1386568" y="1547025"/>
+                  <a:pt x="1366216" y="1547025"/>
+                </a:cubicBezTo>
+                <a:cubicBezTo>
+                  <a:pt x="1238288" y="1543420"/>
+                  <a:pt x="1165601" y="1370405"/>
+                  <a:pt x="1031858" y="1370405"/>
+                </a:cubicBezTo>
+                <a:cubicBezTo>
+                  <a:pt x="950450" y="1370405"/>
+                  <a:pt x="1072563" y="1273083"/>
+                  <a:pt x="1005692" y="1233435"/>
+                </a:cubicBezTo>
+                <a:cubicBezTo>
+                  <a:pt x="991154" y="1222621"/>
+                  <a:pt x="1046396" y="1208203"/>
+                  <a:pt x="1069655" y="1211808"/>
+                </a:cubicBezTo>
+                <a:cubicBezTo>
+                  <a:pt x="1092915" y="1215412"/>
+                  <a:pt x="1113268" y="1240644"/>
+                  <a:pt x="1142342" y="1222621"/>
+                </a:cubicBezTo>
+                <a:cubicBezTo>
+                  <a:pt x="1156879" y="1157741"/>
+                  <a:pt x="1119082" y="1132510"/>
+                  <a:pt x="1084193" y="1114487"/>
+                </a:cubicBezTo>
+                <a:cubicBezTo>
+                  <a:pt x="1008599" y="1071234"/>
+                  <a:pt x="933005" y="1020771"/>
+                  <a:pt x="848689" y="1006353"/>
+                </a:cubicBezTo>
+                <a:cubicBezTo>
+                  <a:pt x="819615" y="1002748"/>
+                  <a:pt x="802169" y="984726"/>
+                  <a:pt x="805077" y="948681"/>
+                </a:cubicBezTo>
+                <a:cubicBezTo>
+                  <a:pt x="810892" y="901822"/>
+                  <a:pt x="839967" y="916240"/>
+                  <a:pt x="863226" y="919844"/>
+                </a:cubicBezTo>
+                <a:cubicBezTo>
+                  <a:pt x="877764" y="923450"/>
+                  <a:pt x="892301" y="934263"/>
+                  <a:pt x="906838" y="909031"/>
+                </a:cubicBezTo>
+                <a:cubicBezTo>
+                  <a:pt x="566666" y="653113"/>
+                  <a:pt x="386404" y="667532"/>
+                  <a:pt x="5527" y="458471"/>
+                </a:cubicBezTo>
+                <a:cubicBezTo>
+                  <a:pt x="89843" y="418822"/>
+                  <a:pt x="150900" y="447658"/>
+                  <a:pt x="209049" y="454867"/>
+                </a:cubicBezTo>
+                <a:cubicBezTo>
+                  <a:pt x="354422" y="472890"/>
+                  <a:pt x="264290" y="505329"/>
+                  <a:pt x="409664" y="526956"/>
+                </a:cubicBezTo>
+                <a:cubicBezTo>
+                  <a:pt x="479443" y="537770"/>
+                  <a:pt x="543407" y="573815"/>
+                  <a:pt x="621908" y="516143"/>
+                </a:cubicBezTo>
+                <a:cubicBezTo>
+                  <a:pt x="674242" y="476494"/>
+                  <a:pt x="758558" y="519747"/>
+                  <a:pt x="822522" y="552188"/>
+                </a:cubicBezTo>
+                <a:cubicBezTo>
+                  <a:pt x="874856" y="581024"/>
+                  <a:pt x="927190" y="588232"/>
+                  <a:pt x="996969" y="552188"/>
+                </a:cubicBezTo>
+                <a:cubicBezTo>
+                  <a:pt x="933005" y="530562"/>
+                  <a:pt x="883579" y="512539"/>
+                  <a:pt x="834151" y="498120"/>
+                </a:cubicBezTo>
+                <a:cubicBezTo>
+                  <a:pt x="793447" y="487307"/>
+                  <a:pt x="770187" y="462076"/>
+                  <a:pt x="773095" y="408008"/>
+                </a:cubicBezTo>
+                <a:cubicBezTo>
+                  <a:pt x="773095" y="379172"/>
+                  <a:pt x="764373" y="339523"/>
+                  <a:pt x="793447" y="325106"/>
+                </a:cubicBezTo>
+                <a:cubicBezTo>
+                  <a:pt x="816707" y="310688"/>
+                  <a:pt x="848689" y="325106"/>
+                  <a:pt x="860319" y="350336"/>
+                </a:cubicBezTo>
+                <a:cubicBezTo>
+                  <a:pt x="874856" y="397195"/>
+                  <a:pt x="889393" y="440449"/>
+                  <a:pt x="938820" y="444054"/>
+                </a:cubicBezTo>
+                <a:cubicBezTo>
+                  <a:pt x="1005692" y="451262"/>
+                  <a:pt x="967894" y="422426"/>
+                  <a:pt x="956265" y="386381"/>
+                </a:cubicBezTo>
+                <a:cubicBezTo>
+                  <a:pt x="944635" y="346733"/>
+                  <a:pt x="979525" y="335919"/>
+                  <a:pt x="1002784" y="343127"/>
+                </a:cubicBezTo>
+                <a:cubicBezTo>
+                  <a:pt x="1090008" y="375569"/>
+                  <a:pt x="1180139" y="317897"/>
+                  <a:pt x="1270270" y="364755"/>
+                </a:cubicBezTo>
+                <a:cubicBezTo>
+                  <a:pt x="1247011" y="249411"/>
+                  <a:pt x="1197583" y="198949"/>
+                  <a:pt x="1092915" y="180926"/>
+                </a:cubicBezTo>
+                <a:cubicBezTo>
+                  <a:pt x="1055118" y="177322"/>
+                  <a:pt x="1014414" y="184530"/>
+                  <a:pt x="979525" y="152090"/>
+                </a:cubicBezTo>
+                <a:cubicBezTo>
+                  <a:pt x="959172" y="134068"/>
+                  <a:pt x="938820" y="112441"/>
+                  <a:pt x="953358" y="76396"/>
+                </a:cubicBezTo>
+                <a:cubicBezTo>
+                  <a:pt x="962080" y="51165"/>
+                  <a:pt x="985339" y="51165"/>
+                  <a:pt x="1005692" y="58373"/>
+                </a:cubicBezTo>
+                <a:cubicBezTo>
+                  <a:pt x="1090008" y="98023"/>
+                  <a:pt x="1180139" y="108837"/>
+                  <a:pt x="1267362" y="123254"/>
+                </a:cubicBezTo>
+                <a:cubicBezTo>
+                  <a:pt x="1281900" y="126859"/>
+                  <a:pt x="1296437" y="134068"/>
+                  <a:pt x="1310975" y="98023"/>
+                </a:cubicBezTo>
+                <a:cubicBezTo>
+                  <a:pt x="1260095" y="81803"/>
+                  <a:pt x="1209941" y="62879"/>
+                  <a:pt x="1159787" y="43505"/>
+                </a:cubicBezTo>
+                <a:close/>
+              </a:path>
+            </a:pathLst>
+          </a:custGeom>
+        </p:spPr>
+      </p:pic>
+    </p:spTree>
+    <p:extLst>
+      <p:ext uri="{BB962C8B-B14F-4D97-AF65-F5344CB8AC3E}">
+        <p14:creationId xmlns:p14="http://schemas.microsoft.com/office/powerpoint/2010/main" val="3792638814"/>
+      </p:ext>
+    </p:extLst>
+  </p:cSld>
+  <p:clrMapOvr>
+    <a:masterClrMapping/>
+  </p:clrMapOvr>
 </p:sld>
 </file>
 

</xml_diff>

<commit_message>
changed metadata in fixture
</commit_message>
<xml_diff>
--- a/tests/fixtures/integration/pptx/basic.pptx
+++ b/tests/fixtures/integration/pptx/basic.pptx
@@ -1,23 +1,27 @@
 
 <file path=ppt/presentation.xml><?xml version="1.0" encoding="utf-8"?>
-<p:presentation xmlns:a="http://schemas.openxmlformats.org/drawingml/2006/main" xmlns:r="http://schemas.openxmlformats.org/officeDocument/2006/relationships" xmlns:p="http://schemas.openxmlformats.org/presentationml/2006/main" saveSubsetFonts="1">
+<!--Generated by Aspose.Slides for .NET 24.12-->
+<p:presentation xmlns:r="http://schemas.openxmlformats.org/officeDocument/2006/relationships" xmlns:a="http://schemas.openxmlformats.org/drawingml/2006/main" xmlns:p="http://schemas.openxmlformats.org/presentationml/2006/main" saveSubsetFonts="1">
   <p:sldMasterIdLst>
-    <p:sldMasterId id="2147483648" r:id="rId1"/>
+    <p:sldMasterId id="2147483648" r:id="rId2"/>
   </p:sldMasterIdLst>
   <p:notesMasterIdLst>
-    <p:notesMasterId r:id="rId9"/>
+    <p:notesMasterId r:id="rId3"/>
   </p:notesMasterIdLst>
   <p:sldIdLst>
-    <p:sldId id="257" r:id="rId2"/>
-    <p:sldId id="258" r:id="rId3"/>
-    <p:sldId id="259" r:id="rId4"/>
-    <p:sldId id="260" r:id="rId5"/>
-    <p:sldId id="261" r:id="rId6"/>
-    <p:sldId id="262" r:id="rId7"/>
-    <p:sldId id="264" r:id="rId8"/>
+    <p:sldId id="257" r:id="rId4"/>
+    <p:sldId id="258" r:id="rId5"/>
+    <p:sldId id="259" r:id="rId6"/>
+    <p:sldId id="260" r:id="rId7"/>
+    <p:sldId id="261" r:id="rId8"/>
+    <p:sldId id="262" r:id="rId9"/>
+    <p:sldId id="264" r:id="rId10"/>
   </p:sldIdLst>
   <p:sldSz cx="12192000" cy="6858000"/>
   <p:notesSz cx="6858000" cy="9144000"/>
+  <p:custDataLst>
+    <p:tags r:id="rId11"/>
+  </p:custDataLst>
   <p:defaultTextStyle>
     <a:defPPr>
       <a:defRPr lang="de-DE"/>
@@ -122,24 +126,25 @@
 </file>
 
 <file path=ppt/authors.xml><?xml version="1.0" encoding="utf-8"?>
-<p188:authorLst xmlns:a="http://schemas.openxmlformats.org/drawingml/2006/main" xmlns:r="http://schemas.openxmlformats.org/officeDocument/2006/relationships" xmlns:p188="http://schemas.microsoft.com/office/powerpoint/2018/8/main">
+<p188:authorLst xmlns:p="http://schemas.openxmlformats.org/presentationml/2006/main" xmlns:p188="http://schemas.microsoft.com/office/powerpoint/2018/8/main">
   <p188:author id="{D6AF5E41-902B-1056-47EF-CEA8025B62D5}" name="Kruthoff, Nils" initials="NK" userId="S::nils.kruthoff@iu-study.org::9b9b4e9a-bbb3-4541-943b-c53e532aa73b" providerId="AD"/>
 </p188:authorLst>
 </file>
 
-<file path=ppt/comments/modernComment_106_EF12CCAC.xml><?xml version="1.0" encoding="utf-8"?>
-<p188:cmLst xmlns:a="http://schemas.openxmlformats.org/drawingml/2006/main" xmlns:r="http://schemas.openxmlformats.org/officeDocument/2006/relationships" xmlns:p188="http://schemas.microsoft.com/office/powerpoint/2018/8/main">
-  <p188:cm id="{4323C402-AE77-4765-A282-91431275213D}" authorId="{D6AF5E41-902B-1056-47EF-CEA8025B62D5}" created="2026-07-12T22:26:25.163">
-    <pc:sldMkLst xmlns:pc="http://schemas.microsoft.com/office/powerpoint/2013/main/command">
+<file path=ppt/comments/moderncomment1.xml><?xml version="1.0" encoding="utf-8"?>
+<p188:cmLst xmlns:pc="http://schemas.microsoft.com/office/powerpoint/2013/main/command" xmlns:ac="http://schemas.microsoft.com/office/drawing/2013/main/command" xmlns:a="http://schemas.openxmlformats.org/drawingml/2006/main" xmlns:r="http://schemas.openxmlformats.org/officeDocument/2006/relationships" xmlns:m="http://schemas.openxmlformats.org/officeDocument/2006/math" xmlns:w="http://schemas.openxmlformats.org/wordprocessingml/2006/main" xmlns:wp="http://schemas.openxmlformats.org/drawingml/2006/wordprocessingDrawing" xmlns:a14="http://schemas.microsoft.com/office/drawing/2010/main" xmlns:p="http://schemas.openxmlformats.org/presentationml/2006/main" xmlns:p188="http://schemas.microsoft.com/office/powerpoint/2018/8/main">
+  <p188:cm id="{4323C402-AE77-4765-A282-91431275213D}" authorId="{D6AF5E41-902B-1056-47EF-CEA8025B62D5}" created="2026-07-12T22:26:25.1630000">
+    <pc:sldMkLst>
       <pc:docMk/>
       <pc:sldMk cId="4010986668" sldId="262"/>
     </pc:sldMkLst>
+    <p188:pos x="0" y="0"/>
     <p188:txBody>
       <a:bodyPr/>
       <a:lstStyle/>
       <a:p>
         <a:r>
-          <a:rPr lang="de-DE"/>
+          <a:rPr/>
           <a:t>Comment</a:t>
         </a:r>
       </a:p>
@@ -149,8 +154,8 @@
 </file>
 
 <file path=ppt/notesMasters/notesMaster1.xml><?xml version="1.0" encoding="utf-8"?>
-<p:notesMaster xmlns:a="http://schemas.openxmlformats.org/drawingml/2006/main" xmlns:r="http://schemas.openxmlformats.org/officeDocument/2006/relationships" xmlns:p="http://schemas.openxmlformats.org/presentationml/2006/main">
-  <p:cSld>
+<p:notesMaster xmlns:a="http://schemas.openxmlformats.org/drawingml/2006/main" xmlns:r="http://schemas.openxmlformats.org/officeDocument/2006/relationships" xmlns:m="http://schemas.openxmlformats.org/officeDocument/2006/math" xmlns:w="http://schemas.openxmlformats.org/wordprocessingml/2006/main" xmlns:wp="http://schemas.openxmlformats.org/drawingml/2006/wordprocessingDrawing" xmlns:a14="http://schemas.microsoft.com/office/drawing/2010/main" xmlns:mc="http://schemas.openxmlformats.org/markup-compatibility/2006" xmlns:p14="http://schemas.microsoft.com/office/powerpoint/2010/main" xmlns:p="http://schemas.openxmlformats.org/presentationml/2006/main">
+  <p:cSld name="">
     <p:bg>
       <p:bgRef idx="1001">
         <a:schemeClr val="bg1"/>
@@ -166,8 +171,6 @@
         <a:xfrm>
           <a:off x="0" y="0"/>
           <a:ext cx="0" cy="0"/>
-          <a:chOff x="0" y="0"/>
-          <a:chExt cx="0" cy="0"/>
         </a:xfrm>
       </p:grpSpPr>
       <p:sp>
@@ -261,13 +264,6 @@
             </a:solidFill>
           </a:ln>
         </p:spPr>
-        <p:txBody>
-          <a:bodyPr vert="horz" lIns="91440" tIns="45720" rIns="91440" bIns="45720" rtlCol="0" anchor="ctr"/>
-          <a:lstStyle/>
-          <a:p>
-            <a:endParaRPr lang="de-DE"/>
-          </a:p>
-        </p:txBody>
       </p:sp>
       <p:sp>
         <p:nvSpPr>
@@ -397,7 +393,7 @@
     </p:spTree>
     <p:extLst>
       <p:ext uri="{BB962C8B-B14F-4D97-AF65-F5344CB8AC3E}">
-        <p14:creationId xmlns:p14="http://schemas.microsoft.com/office/powerpoint/2010/main" val="3972748546"/>
+        <p14:creationId val="3972748546"/>
       </p:ext>
     </p:extLst>
   </p:cSld>
@@ -498,8 +494,8 @@
 </file>
 
 <file path=ppt/notesSlides/notesSlide1.xml><?xml version="1.0" encoding="utf-8"?>
-<p:notes xmlns:a="http://schemas.openxmlformats.org/drawingml/2006/main" xmlns:r="http://schemas.openxmlformats.org/officeDocument/2006/relationships" xmlns:p="http://schemas.openxmlformats.org/presentationml/2006/main">
-  <p:cSld>
+<p:notes xmlns:a="http://schemas.openxmlformats.org/drawingml/2006/main" xmlns:r="http://schemas.openxmlformats.org/officeDocument/2006/relationships" xmlns:m="http://schemas.openxmlformats.org/officeDocument/2006/math" xmlns:w="http://schemas.openxmlformats.org/wordprocessingml/2006/main" xmlns:wp="http://schemas.openxmlformats.org/drawingml/2006/wordprocessingDrawing" xmlns:a14="http://schemas.microsoft.com/office/drawing/2010/main" xmlns:mc="http://schemas.openxmlformats.org/markup-compatibility/2006" xmlns:p14="http://schemas.microsoft.com/office/powerpoint/2010/main" xmlns:p="http://schemas.openxmlformats.org/presentationml/2006/main">
+  <p:cSld name="">
     <p:spTree>
       <p:nvGrpSpPr>
         <p:cNvPr id="1" name=""/>
@@ -510,8 +506,6 @@
         <a:xfrm>
           <a:off x="0" y="0"/>
           <a:ext cx="0" cy="0"/>
-          <a:chOff x="0" y="0"/>
-          <a:chExt cx="0" cy="0"/>
         </a:xfrm>
       </p:grpSpPr>
       <p:sp>
@@ -546,20 +540,19 @@
                 <a:spcPct val="100000"/>
               </a:lnSpc>
               <a:spcBef>
-                <a:spcPts val="0"/>
+                <a:spcPct val="0"/>
               </a:spcBef>
               <a:spcAft>
-                <a:spcPts val="0"/>
+                <a:spcPct val="0"/>
               </a:spcAft>
               <a:buClrTx/>
               <a:buSzTx/>
               <a:buFontTx/>
               <a:buNone/>
-              <a:tabLst/>
               <a:defRPr/>
             </a:pPr>
             <a:r>
-              <a:rPr lang="de-DE" sz="1200" kern="1200" dirty="0">
+              <a:rPr lang="de-DE" sz="1200" kern="1200">
                 <a:solidFill>
                   <a:schemeClr val="tx1"/>
                 </a:solidFill>
@@ -568,21 +561,9 @@
                 <a:ea typeface="+mn-ea"/>
                 <a:cs typeface="+mn-cs"/>
               </a:rPr>
-              <a:t>Speaker </a:t>
-            </a:r>
-            <a:r>
-              <a:rPr lang="de-DE" sz="1200" kern="1200" dirty="0" err="1">
-                <a:solidFill>
-                  <a:schemeClr val="tx1"/>
-                </a:solidFill>
-                <a:effectLst/>
-                <a:latin typeface="+mn-lt"/>
-                <a:ea typeface="+mn-ea"/>
-                <a:cs typeface="+mn-cs"/>
-              </a:rPr>
-              <a:t>notes</a:t>
-            </a:r>
-            <a:endParaRPr lang="de-DE" sz="1200" kern="1200" dirty="0">
+              <a:t>Speaker notes</a:t>
+            </a:r>
+            <a:endParaRPr lang="de-DE" sz="1200" kern="1200">
               <a:solidFill>
                 <a:schemeClr val="tx1"/>
               </a:solidFill>
@@ -620,7 +601,7 @@
     </p:spTree>
     <p:extLst>
       <p:ext uri="{BB962C8B-B14F-4D97-AF65-F5344CB8AC3E}">
-        <p14:creationId xmlns:p14="http://schemas.microsoft.com/office/powerpoint/2010/main" val="3561287286"/>
+        <p14:creationId val="3561287286"/>
       </p:ext>
     </p:extLst>
   </p:cSld>
@@ -631,7 +612,7 @@
 </file>
 
 <file path=ppt/slideLayouts/slideLayout1.xml><?xml version="1.0" encoding="utf-8"?>
-<p:sldLayout xmlns:a="http://schemas.openxmlformats.org/drawingml/2006/main" xmlns:r="http://schemas.openxmlformats.org/officeDocument/2006/relationships" xmlns:p="http://schemas.openxmlformats.org/presentationml/2006/main" type="title" preserve="1">
+<p:sldLayout xmlns:a="http://schemas.openxmlformats.org/drawingml/2006/main" xmlns:r="http://schemas.openxmlformats.org/officeDocument/2006/relationships" xmlns:m="http://schemas.openxmlformats.org/officeDocument/2006/math" xmlns:w="http://schemas.openxmlformats.org/wordprocessingml/2006/main" xmlns:wp="http://schemas.openxmlformats.org/drawingml/2006/wordprocessingDrawing" xmlns:a14="http://schemas.microsoft.com/office/drawing/2010/main" xmlns:mc="http://schemas.openxmlformats.org/markup-compatibility/2006" xmlns:p14="http://schemas.microsoft.com/office/powerpoint/2010/main" xmlns:p15="http://schemas.microsoft.com/office/powerpoint/2012/main" xmlns:p159="http://schemas.microsoft.com/office/powerpoint/2015/09/main" xmlns:p="http://schemas.openxmlformats.org/presentationml/2006/main" type="title" preserve="1">
   <p:cSld name="Titelfolie">
     <p:spTree>
       <p:nvGrpSpPr>
@@ -643,8 +624,6 @@
         <a:xfrm>
           <a:off x="0" y="0"/>
           <a:ext cx="0" cy="0"/>
-          <a:chOff x="0" y="0"/>
-          <a:chExt cx="0" cy="0"/>
         </a:xfrm>
       </p:grpSpPr>
       <p:sp>
@@ -840,18 +819,20 @@
     </p:spTree>
     <p:extLst>
       <p:ext uri="{BB962C8B-B14F-4D97-AF65-F5344CB8AC3E}">
-        <p14:creationId xmlns:p14="http://schemas.microsoft.com/office/powerpoint/2010/main" val="2027243334"/>
+        <p14:creationId val="2027243334"/>
       </p:ext>
     </p:extLst>
   </p:cSld>
   <p:clrMapOvr>
     <a:masterClrMapping/>
   </p:clrMapOvr>
+  <p:transition/>
+  <p:timing/>
 </p:sldLayout>
 </file>
 
 <file path=ppt/slideLayouts/slideLayout10.xml><?xml version="1.0" encoding="utf-8"?>
-<p:sldLayout xmlns:a="http://schemas.openxmlformats.org/drawingml/2006/main" xmlns:r="http://schemas.openxmlformats.org/officeDocument/2006/relationships" xmlns:p="http://schemas.openxmlformats.org/presentationml/2006/main" type="vertTx" preserve="1">
+<p:sldLayout xmlns:a="http://schemas.openxmlformats.org/drawingml/2006/main" xmlns:r="http://schemas.openxmlformats.org/officeDocument/2006/relationships" xmlns:m="http://schemas.openxmlformats.org/officeDocument/2006/math" xmlns:w="http://schemas.openxmlformats.org/wordprocessingml/2006/main" xmlns:wp="http://schemas.openxmlformats.org/drawingml/2006/wordprocessingDrawing" xmlns:a14="http://schemas.microsoft.com/office/drawing/2010/main" xmlns:mc="http://schemas.openxmlformats.org/markup-compatibility/2006" xmlns:p14="http://schemas.microsoft.com/office/powerpoint/2010/main" xmlns:p15="http://schemas.microsoft.com/office/powerpoint/2012/main" xmlns:p159="http://schemas.microsoft.com/office/powerpoint/2015/09/main" xmlns:p="http://schemas.openxmlformats.org/presentationml/2006/main" type="vertTx" preserve="1">
   <p:cSld name="Titel und vertikaler Text">
     <p:spTree>
       <p:nvGrpSpPr>
@@ -863,8 +844,6 @@
         <a:xfrm>
           <a:off x="0" y="0"/>
           <a:ext cx="0" cy="0"/>
-          <a:chOff x="0" y="0"/>
-          <a:chExt cx="0" cy="0"/>
         </a:xfrm>
       </p:grpSpPr>
       <p:sp>
@@ -1038,18 +1017,20 @@
     </p:spTree>
     <p:extLst>
       <p:ext uri="{BB962C8B-B14F-4D97-AF65-F5344CB8AC3E}">
-        <p14:creationId xmlns:p14="http://schemas.microsoft.com/office/powerpoint/2010/main" val="2671506248"/>
+        <p14:creationId val="2671506248"/>
       </p:ext>
     </p:extLst>
   </p:cSld>
   <p:clrMapOvr>
     <a:masterClrMapping/>
   </p:clrMapOvr>
+  <p:transition/>
+  <p:timing/>
 </p:sldLayout>
 </file>
 
 <file path=ppt/slideLayouts/slideLayout11.xml><?xml version="1.0" encoding="utf-8"?>
-<p:sldLayout xmlns:a="http://schemas.openxmlformats.org/drawingml/2006/main" xmlns:r="http://schemas.openxmlformats.org/officeDocument/2006/relationships" xmlns:p="http://schemas.openxmlformats.org/presentationml/2006/main" type="vertTitleAndTx" preserve="1">
+<p:sldLayout xmlns:a="http://schemas.openxmlformats.org/drawingml/2006/main" xmlns:r="http://schemas.openxmlformats.org/officeDocument/2006/relationships" xmlns:m="http://schemas.openxmlformats.org/officeDocument/2006/math" xmlns:w="http://schemas.openxmlformats.org/wordprocessingml/2006/main" xmlns:wp="http://schemas.openxmlformats.org/drawingml/2006/wordprocessingDrawing" xmlns:a14="http://schemas.microsoft.com/office/drawing/2010/main" xmlns:mc="http://schemas.openxmlformats.org/markup-compatibility/2006" xmlns:p14="http://schemas.microsoft.com/office/powerpoint/2010/main" xmlns:p15="http://schemas.microsoft.com/office/powerpoint/2012/main" xmlns:p159="http://schemas.microsoft.com/office/powerpoint/2015/09/main" xmlns:p="http://schemas.openxmlformats.org/presentationml/2006/main" type="vertTitleAndTx" preserve="1">
   <p:cSld name="Vertikaler Titel und Text">
     <p:spTree>
       <p:nvGrpSpPr>
@@ -1061,8 +1042,6 @@
         <a:xfrm>
           <a:off x="0" y="0"/>
           <a:ext cx="0" cy="0"/>
-          <a:chOff x="0" y="0"/>
-          <a:chExt cx="0" cy="0"/>
         </a:xfrm>
       </p:grpSpPr>
       <p:sp>
@@ -1246,18 +1225,20 @@
     </p:spTree>
     <p:extLst>
       <p:ext uri="{BB962C8B-B14F-4D97-AF65-F5344CB8AC3E}">
-        <p14:creationId xmlns:p14="http://schemas.microsoft.com/office/powerpoint/2010/main" val="3419224650"/>
+        <p14:creationId val="3419224650"/>
       </p:ext>
     </p:extLst>
   </p:cSld>
   <p:clrMapOvr>
     <a:masterClrMapping/>
   </p:clrMapOvr>
+  <p:transition/>
+  <p:timing/>
 </p:sldLayout>
 </file>
 
 <file path=ppt/slideLayouts/slideLayout2.xml><?xml version="1.0" encoding="utf-8"?>
-<p:sldLayout xmlns:a="http://schemas.openxmlformats.org/drawingml/2006/main" xmlns:r="http://schemas.openxmlformats.org/officeDocument/2006/relationships" xmlns:p="http://schemas.openxmlformats.org/presentationml/2006/main" type="obj" preserve="1">
+<p:sldLayout xmlns:a="http://schemas.openxmlformats.org/drawingml/2006/main" xmlns:r="http://schemas.openxmlformats.org/officeDocument/2006/relationships" xmlns:m="http://schemas.openxmlformats.org/officeDocument/2006/math" xmlns:w="http://schemas.openxmlformats.org/wordprocessingml/2006/main" xmlns:wp="http://schemas.openxmlformats.org/drawingml/2006/wordprocessingDrawing" xmlns:a14="http://schemas.microsoft.com/office/drawing/2010/main" xmlns:mc="http://schemas.openxmlformats.org/markup-compatibility/2006" xmlns:p14="http://schemas.microsoft.com/office/powerpoint/2010/main" xmlns:p15="http://schemas.microsoft.com/office/powerpoint/2012/main" xmlns:p159="http://schemas.microsoft.com/office/powerpoint/2015/09/main" xmlns:p="http://schemas.openxmlformats.org/presentationml/2006/main" type="obj" preserve="1">
   <p:cSld name="Titel und Inhalt">
     <p:spTree>
       <p:nvGrpSpPr>
@@ -1269,8 +1250,6 @@
         <a:xfrm>
           <a:off x="0" y="0"/>
           <a:ext cx="0" cy="0"/>
-          <a:chOff x="0" y="0"/>
-          <a:chExt cx="0" cy="0"/>
         </a:xfrm>
       </p:grpSpPr>
       <p:sp>
@@ -1444,18 +1423,20 @@
     </p:spTree>
     <p:extLst>
       <p:ext uri="{BB962C8B-B14F-4D97-AF65-F5344CB8AC3E}">
-        <p14:creationId xmlns:p14="http://schemas.microsoft.com/office/powerpoint/2010/main" val="3663937932"/>
+        <p14:creationId val="3663937932"/>
       </p:ext>
     </p:extLst>
   </p:cSld>
   <p:clrMapOvr>
     <a:masterClrMapping/>
   </p:clrMapOvr>
+  <p:transition/>
+  <p:timing/>
 </p:sldLayout>
 </file>
 
 <file path=ppt/slideLayouts/slideLayout3.xml><?xml version="1.0" encoding="utf-8"?>
-<p:sldLayout xmlns:a="http://schemas.openxmlformats.org/drawingml/2006/main" xmlns:r="http://schemas.openxmlformats.org/officeDocument/2006/relationships" xmlns:p="http://schemas.openxmlformats.org/presentationml/2006/main" type="secHead" preserve="1">
+<p:sldLayout xmlns:a="http://schemas.openxmlformats.org/drawingml/2006/main" xmlns:r="http://schemas.openxmlformats.org/officeDocument/2006/relationships" xmlns:m="http://schemas.openxmlformats.org/officeDocument/2006/math" xmlns:w="http://schemas.openxmlformats.org/wordprocessingml/2006/main" xmlns:wp="http://schemas.openxmlformats.org/drawingml/2006/wordprocessingDrawing" xmlns:a14="http://schemas.microsoft.com/office/drawing/2010/main" xmlns:mc="http://schemas.openxmlformats.org/markup-compatibility/2006" xmlns:p14="http://schemas.microsoft.com/office/powerpoint/2010/main" xmlns:p15="http://schemas.microsoft.com/office/powerpoint/2012/main" xmlns:p159="http://schemas.microsoft.com/office/powerpoint/2015/09/main" xmlns:p="http://schemas.openxmlformats.org/presentationml/2006/main" type="secHead" preserve="1">
   <p:cSld name="Abschnitts-&#10;überschrift">
     <p:spTree>
       <p:nvGrpSpPr>
@@ -1467,8 +1448,6 @@
         <a:xfrm>
           <a:off x="0" y="0"/>
           <a:ext cx="0" cy="0"/>
-          <a:chOff x="0" y="0"/>
-          <a:chExt cx="0" cy="0"/>
         </a:xfrm>
       </p:grpSpPr>
       <p:sp>
@@ -1719,18 +1698,20 @@
     </p:spTree>
     <p:extLst>
       <p:ext uri="{BB962C8B-B14F-4D97-AF65-F5344CB8AC3E}">
-        <p14:creationId xmlns:p14="http://schemas.microsoft.com/office/powerpoint/2010/main" val="3386285398"/>
+        <p14:creationId val="3386285398"/>
       </p:ext>
     </p:extLst>
   </p:cSld>
   <p:clrMapOvr>
     <a:masterClrMapping/>
   </p:clrMapOvr>
+  <p:transition/>
+  <p:timing/>
 </p:sldLayout>
 </file>
 
 <file path=ppt/slideLayouts/slideLayout4.xml><?xml version="1.0" encoding="utf-8"?>
-<p:sldLayout xmlns:a="http://schemas.openxmlformats.org/drawingml/2006/main" xmlns:r="http://schemas.openxmlformats.org/officeDocument/2006/relationships" xmlns:p="http://schemas.openxmlformats.org/presentationml/2006/main" type="twoObj" preserve="1">
+<p:sldLayout xmlns:a="http://schemas.openxmlformats.org/drawingml/2006/main" xmlns:r="http://schemas.openxmlformats.org/officeDocument/2006/relationships" xmlns:m="http://schemas.openxmlformats.org/officeDocument/2006/math" xmlns:w="http://schemas.openxmlformats.org/wordprocessingml/2006/main" xmlns:wp="http://schemas.openxmlformats.org/drawingml/2006/wordprocessingDrawing" xmlns:a14="http://schemas.microsoft.com/office/drawing/2010/main" xmlns:mc="http://schemas.openxmlformats.org/markup-compatibility/2006" xmlns:p14="http://schemas.microsoft.com/office/powerpoint/2010/main" xmlns:p15="http://schemas.microsoft.com/office/powerpoint/2012/main" xmlns:p159="http://schemas.microsoft.com/office/powerpoint/2015/09/main" xmlns:p="http://schemas.openxmlformats.org/presentationml/2006/main" type="twoObj" preserve="1">
   <p:cSld name="Zwei Inhalte">
     <p:spTree>
       <p:nvGrpSpPr>
@@ -1742,8 +1723,6 @@
         <a:xfrm>
           <a:off x="0" y="0"/>
           <a:ext cx="0" cy="0"/>
-          <a:chOff x="0" y="0"/>
-          <a:chExt cx="0" cy="0"/>
         </a:xfrm>
       </p:grpSpPr>
       <p:sp>
@@ -1984,18 +1963,20 @@
     </p:spTree>
     <p:extLst>
       <p:ext uri="{BB962C8B-B14F-4D97-AF65-F5344CB8AC3E}">
-        <p14:creationId xmlns:p14="http://schemas.microsoft.com/office/powerpoint/2010/main" val="4239504866"/>
+        <p14:creationId val="4239504866"/>
       </p:ext>
     </p:extLst>
   </p:cSld>
   <p:clrMapOvr>
     <a:masterClrMapping/>
   </p:clrMapOvr>
+  <p:transition/>
+  <p:timing/>
 </p:sldLayout>
 </file>
 
 <file path=ppt/slideLayouts/slideLayout5.xml><?xml version="1.0" encoding="utf-8"?>
-<p:sldLayout xmlns:a="http://schemas.openxmlformats.org/drawingml/2006/main" xmlns:r="http://schemas.openxmlformats.org/officeDocument/2006/relationships" xmlns:p="http://schemas.openxmlformats.org/presentationml/2006/main" type="twoTxTwoObj" preserve="1">
+<p:sldLayout xmlns:a="http://schemas.openxmlformats.org/drawingml/2006/main" xmlns:r="http://schemas.openxmlformats.org/officeDocument/2006/relationships" xmlns:m="http://schemas.openxmlformats.org/officeDocument/2006/math" xmlns:w="http://schemas.openxmlformats.org/wordprocessingml/2006/main" xmlns:wp="http://schemas.openxmlformats.org/drawingml/2006/wordprocessingDrawing" xmlns:a14="http://schemas.microsoft.com/office/drawing/2010/main" xmlns:mc="http://schemas.openxmlformats.org/markup-compatibility/2006" xmlns:p14="http://schemas.microsoft.com/office/powerpoint/2010/main" xmlns:p15="http://schemas.microsoft.com/office/powerpoint/2012/main" xmlns:p159="http://schemas.microsoft.com/office/powerpoint/2015/09/main" xmlns:p="http://schemas.openxmlformats.org/presentationml/2006/main" type="twoTxTwoObj" preserve="1">
   <p:cSld name="Vergleich">
     <p:spTree>
       <p:nvGrpSpPr>
@@ -2007,8 +1988,6 @@
         <a:xfrm>
           <a:off x="0" y="0"/>
           <a:ext cx="0" cy="0"/>
-          <a:chOff x="0" y="0"/>
-          <a:chExt cx="0" cy="0"/>
         </a:xfrm>
       </p:grpSpPr>
       <p:sp>
@@ -2396,18 +2375,20 @@
     </p:spTree>
     <p:extLst>
       <p:ext uri="{BB962C8B-B14F-4D97-AF65-F5344CB8AC3E}">
-        <p14:creationId xmlns:p14="http://schemas.microsoft.com/office/powerpoint/2010/main" val="1700525978"/>
+        <p14:creationId val="1700525978"/>
       </p:ext>
     </p:extLst>
   </p:cSld>
   <p:clrMapOvr>
     <a:masterClrMapping/>
   </p:clrMapOvr>
+  <p:transition/>
+  <p:timing/>
 </p:sldLayout>
 </file>
 
 <file path=ppt/slideLayouts/slideLayout6.xml><?xml version="1.0" encoding="utf-8"?>
-<p:sldLayout xmlns:a="http://schemas.openxmlformats.org/drawingml/2006/main" xmlns:r="http://schemas.openxmlformats.org/officeDocument/2006/relationships" xmlns:p="http://schemas.openxmlformats.org/presentationml/2006/main" type="titleOnly" preserve="1">
+<p:sldLayout xmlns:a="http://schemas.openxmlformats.org/drawingml/2006/main" xmlns:r="http://schemas.openxmlformats.org/officeDocument/2006/relationships" xmlns:m="http://schemas.openxmlformats.org/officeDocument/2006/math" xmlns:w="http://schemas.openxmlformats.org/wordprocessingml/2006/main" xmlns:wp="http://schemas.openxmlformats.org/drawingml/2006/wordprocessingDrawing" xmlns:a14="http://schemas.microsoft.com/office/drawing/2010/main" xmlns:mc="http://schemas.openxmlformats.org/markup-compatibility/2006" xmlns:p14="http://schemas.microsoft.com/office/powerpoint/2010/main" xmlns:p15="http://schemas.microsoft.com/office/powerpoint/2012/main" xmlns:p159="http://schemas.microsoft.com/office/powerpoint/2015/09/main" xmlns:p="http://schemas.openxmlformats.org/presentationml/2006/main" type="titleOnly" preserve="1">
   <p:cSld name="Nur Titel">
     <p:spTree>
       <p:nvGrpSpPr>
@@ -2419,8 +2400,6 @@
         <a:xfrm>
           <a:off x="0" y="0"/>
           <a:ext cx="0" cy="0"/>
-          <a:chOff x="0" y="0"/>
-          <a:chExt cx="0" cy="0"/>
         </a:xfrm>
       </p:grpSpPr>
       <p:sp>
@@ -2537,18 +2516,20 @@
     </p:spTree>
     <p:extLst>
       <p:ext uri="{BB962C8B-B14F-4D97-AF65-F5344CB8AC3E}">
-        <p14:creationId xmlns:p14="http://schemas.microsoft.com/office/powerpoint/2010/main" val="1669947715"/>
+        <p14:creationId val="1669947715"/>
       </p:ext>
     </p:extLst>
   </p:cSld>
   <p:clrMapOvr>
     <a:masterClrMapping/>
   </p:clrMapOvr>
+  <p:transition/>
+  <p:timing/>
 </p:sldLayout>
 </file>
 
 <file path=ppt/slideLayouts/slideLayout7.xml><?xml version="1.0" encoding="utf-8"?>
-<p:sldLayout xmlns:a="http://schemas.openxmlformats.org/drawingml/2006/main" xmlns:r="http://schemas.openxmlformats.org/officeDocument/2006/relationships" xmlns:p="http://schemas.openxmlformats.org/presentationml/2006/main" type="blank" preserve="1">
+<p:sldLayout xmlns:a="http://schemas.openxmlformats.org/drawingml/2006/main" xmlns:r="http://schemas.openxmlformats.org/officeDocument/2006/relationships" xmlns:m="http://schemas.openxmlformats.org/officeDocument/2006/math" xmlns:w="http://schemas.openxmlformats.org/wordprocessingml/2006/main" xmlns:wp="http://schemas.openxmlformats.org/drawingml/2006/wordprocessingDrawing" xmlns:a14="http://schemas.microsoft.com/office/drawing/2010/main" xmlns:mc="http://schemas.openxmlformats.org/markup-compatibility/2006" xmlns:p14="http://schemas.microsoft.com/office/powerpoint/2010/main" xmlns:p15="http://schemas.microsoft.com/office/powerpoint/2012/main" xmlns:p159="http://schemas.microsoft.com/office/powerpoint/2015/09/main" xmlns:p="http://schemas.openxmlformats.org/presentationml/2006/main" type="blank" preserve="1">
   <p:cSld name="Leer">
     <p:spTree>
       <p:nvGrpSpPr>
@@ -2560,8 +2541,6 @@
         <a:xfrm>
           <a:off x="0" y="0"/>
           <a:ext cx="0" cy="0"/>
-          <a:chOff x="0" y="0"/>
-          <a:chExt cx="0" cy="0"/>
         </a:xfrm>
       </p:grpSpPr>
       <p:sp>
@@ -2650,18 +2629,20 @@
     </p:spTree>
     <p:extLst>
       <p:ext uri="{BB962C8B-B14F-4D97-AF65-F5344CB8AC3E}">
-        <p14:creationId xmlns:p14="http://schemas.microsoft.com/office/powerpoint/2010/main" val="1559360171"/>
+        <p14:creationId val="1559360171"/>
       </p:ext>
     </p:extLst>
   </p:cSld>
   <p:clrMapOvr>
     <a:masterClrMapping/>
   </p:clrMapOvr>
+  <p:transition/>
+  <p:timing/>
 </p:sldLayout>
 </file>
 
 <file path=ppt/slideLayouts/slideLayout8.xml><?xml version="1.0" encoding="utf-8"?>
-<p:sldLayout xmlns:a="http://schemas.openxmlformats.org/drawingml/2006/main" xmlns:r="http://schemas.openxmlformats.org/officeDocument/2006/relationships" xmlns:p="http://schemas.openxmlformats.org/presentationml/2006/main" type="objTx" preserve="1">
+<p:sldLayout xmlns:a="http://schemas.openxmlformats.org/drawingml/2006/main" xmlns:r="http://schemas.openxmlformats.org/officeDocument/2006/relationships" xmlns:m="http://schemas.openxmlformats.org/officeDocument/2006/math" xmlns:w="http://schemas.openxmlformats.org/wordprocessingml/2006/main" xmlns:wp="http://schemas.openxmlformats.org/drawingml/2006/wordprocessingDrawing" xmlns:a14="http://schemas.microsoft.com/office/drawing/2010/main" xmlns:mc="http://schemas.openxmlformats.org/markup-compatibility/2006" xmlns:p14="http://schemas.microsoft.com/office/powerpoint/2010/main" xmlns:p15="http://schemas.microsoft.com/office/powerpoint/2012/main" xmlns:p159="http://schemas.microsoft.com/office/powerpoint/2015/09/main" xmlns:p="http://schemas.openxmlformats.org/presentationml/2006/main" type="objTx" preserve="1">
   <p:cSld name="Inhalt mit Überschrift">
     <p:spTree>
       <p:nvGrpSpPr>
@@ -2673,8 +2654,6 @@
         <a:xfrm>
           <a:off x="0" y="0"/>
           <a:ext cx="0" cy="0"/>
-          <a:chOff x="0" y="0"/>
-          <a:chExt cx="0" cy="0"/>
         </a:xfrm>
       </p:grpSpPr>
       <p:sp>
@@ -2961,18 +2940,20 @@
     </p:spTree>
     <p:extLst>
       <p:ext uri="{BB962C8B-B14F-4D97-AF65-F5344CB8AC3E}">
-        <p14:creationId xmlns:p14="http://schemas.microsoft.com/office/powerpoint/2010/main" val="4256924042"/>
+        <p14:creationId val="4256924042"/>
       </p:ext>
     </p:extLst>
   </p:cSld>
   <p:clrMapOvr>
     <a:masterClrMapping/>
   </p:clrMapOvr>
+  <p:transition/>
+  <p:timing/>
 </p:sldLayout>
 </file>
 
 <file path=ppt/slideLayouts/slideLayout9.xml><?xml version="1.0" encoding="utf-8"?>
-<p:sldLayout xmlns:a="http://schemas.openxmlformats.org/drawingml/2006/main" xmlns:r="http://schemas.openxmlformats.org/officeDocument/2006/relationships" xmlns:p="http://schemas.openxmlformats.org/presentationml/2006/main" type="picTx" preserve="1">
+<p:sldLayout xmlns:a="http://schemas.openxmlformats.org/drawingml/2006/main" xmlns:r="http://schemas.openxmlformats.org/officeDocument/2006/relationships" xmlns:m="http://schemas.openxmlformats.org/officeDocument/2006/math" xmlns:w="http://schemas.openxmlformats.org/wordprocessingml/2006/main" xmlns:wp="http://schemas.openxmlformats.org/drawingml/2006/wordprocessingDrawing" xmlns:a14="http://schemas.microsoft.com/office/drawing/2010/main" xmlns:mc="http://schemas.openxmlformats.org/markup-compatibility/2006" xmlns:p14="http://schemas.microsoft.com/office/powerpoint/2010/main" xmlns:p15="http://schemas.microsoft.com/office/powerpoint/2012/main" xmlns:p159="http://schemas.microsoft.com/office/powerpoint/2015/09/main" xmlns:p="http://schemas.openxmlformats.org/presentationml/2006/main" type="picTx" preserve="1">
   <p:cSld name="Bild mit Überschrift">
     <p:spTree>
       <p:nvGrpSpPr>
@@ -2984,8 +2965,6 @@
         <a:xfrm>
           <a:off x="0" y="0"/>
           <a:ext cx="0" cy="0"/>
-          <a:chOff x="0" y="0"/>
-          <a:chExt cx="0" cy="0"/>
         </a:xfrm>
       </p:grpSpPr>
       <p:sp>
@@ -3249,18 +3228,20 @@
     </p:spTree>
     <p:extLst>
       <p:ext uri="{BB962C8B-B14F-4D97-AF65-F5344CB8AC3E}">
-        <p14:creationId xmlns:p14="http://schemas.microsoft.com/office/powerpoint/2010/main" val="348169875"/>
+        <p14:creationId val="348169875"/>
       </p:ext>
     </p:extLst>
   </p:cSld>
   <p:clrMapOvr>
     <a:masterClrMapping/>
   </p:clrMapOvr>
+  <p:transition/>
+  <p:timing/>
 </p:sldLayout>
 </file>
 
 <file path=ppt/slideMasters/slideMaster1.xml><?xml version="1.0" encoding="utf-8"?>
-<p:sldMaster xmlns:a="http://schemas.openxmlformats.org/drawingml/2006/main" xmlns:r="http://schemas.openxmlformats.org/officeDocument/2006/relationships" xmlns:p="http://schemas.openxmlformats.org/presentationml/2006/main">
+<p:sldMaster xmlns:a="http://schemas.openxmlformats.org/drawingml/2006/main" xmlns:r="http://schemas.openxmlformats.org/officeDocument/2006/relationships" xmlns:m="http://schemas.openxmlformats.org/officeDocument/2006/math" xmlns:w="http://schemas.openxmlformats.org/wordprocessingml/2006/main" xmlns:wp="http://schemas.openxmlformats.org/drawingml/2006/wordprocessingDrawing" xmlns:a14="http://schemas.microsoft.com/office/drawing/2010/main" xmlns:mc="http://schemas.openxmlformats.org/markup-compatibility/2006" xmlns:p14="http://schemas.microsoft.com/office/powerpoint/2010/main" xmlns:p15="http://schemas.microsoft.com/office/powerpoint/2012/main" xmlns:p159="http://schemas.microsoft.com/office/powerpoint/2015/09/main" xmlns:p="http://schemas.openxmlformats.org/presentationml/2006/main">
   <p:cSld>
     <p:bg>
       <p:bgRef idx="1001">
@@ -3277,8 +3258,6 @@
         <a:xfrm>
           <a:off x="0" y="0"/>
           <a:ext cx="0" cy="0"/>
-          <a:chOff x="0" y="0"/>
-          <a:chExt cx="0" cy="0"/>
         </a:xfrm>
       </p:grpSpPr>
       <p:sp>
@@ -3526,7 +3505,7 @@
     </p:spTree>
     <p:extLst>
       <p:ext uri="{BB962C8B-B14F-4D97-AF65-F5344CB8AC3E}">
-        <p14:creationId xmlns:p14="http://schemas.microsoft.com/office/powerpoint/2010/main" val="448204933"/>
+        <p14:creationId val="448204933"/>
       </p:ext>
     </p:extLst>
   </p:cSld>
@@ -3544,6 +3523,8 @@
     <p:sldLayoutId id="2147483658" r:id="rId10"/>
     <p:sldLayoutId id="2147483659" r:id="rId11"/>
   </p:sldLayoutIdLst>
+  <p:transition/>
+  <p:timing/>
   <p:txStyles>
     <p:titleStyle>
       <a:lvl1pPr algn="l" defTabSz="914400" rtl="0" eaLnBrk="1" latinLnBrk="0" hangingPunct="1">
@@ -3572,7 +3553,7 @@
         <a:spcBef>
           <a:spcPts val="1000"/>
         </a:spcBef>
-        <a:buFont typeface="Arial" panose="020B0604020202020204" pitchFamily="34" charset="0"/>
+        <a:buFont typeface="Arial" panose="020b0604020202020204" pitchFamily="34" charset="0"/>
         <a:buChar char="•"/>
         <a:defRPr sz="2800" kern="1200">
           <a:solidFill>
@@ -3590,7 +3571,7 @@
         <a:spcBef>
           <a:spcPts val="500"/>
         </a:spcBef>
-        <a:buFont typeface="Arial" panose="020B0604020202020204" pitchFamily="34" charset="0"/>
+        <a:buFont typeface="Arial" panose="020b0604020202020204" pitchFamily="34" charset="0"/>
         <a:buChar char="•"/>
         <a:defRPr sz="2400" kern="1200">
           <a:solidFill>
@@ -3608,7 +3589,7 @@
         <a:spcBef>
           <a:spcPts val="500"/>
         </a:spcBef>
-        <a:buFont typeface="Arial" panose="020B0604020202020204" pitchFamily="34" charset="0"/>
+        <a:buFont typeface="Arial" panose="020b0604020202020204" pitchFamily="34" charset="0"/>
         <a:buChar char="•"/>
         <a:defRPr sz="2000" kern="1200">
           <a:solidFill>
@@ -3626,7 +3607,7 @@
         <a:spcBef>
           <a:spcPts val="500"/>
         </a:spcBef>
-        <a:buFont typeface="Arial" panose="020B0604020202020204" pitchFamily="34" charset="0"/>
+        <a:buFont typeface="Arial" panose="020b0604020202020204" pitchFamily="34" charset="0"/>
         <a:buChar char="•"/>
         <a:defRPr sz="1800" kern="1200">
           <a:solidFill>
@@ -3644,7 +3625,7 @@
         <a:spcBef>
           <a:spcPts val="500"/>
         </a:spcBef>
-        <a:buFont typeface="Arial" panose="020B0604020202020204" pitchFamily="34" charset="0"/>
+        <a:buFont typeface="Arial" panose="020b0604020202020204" pitchFamily="34" charset="0"/>
         <a:buChar char="•"/>
         <a:defRPr sz="1800" kern="1200">
           <a:solidFill>
@@ -3662,7 +3643,7 @@
         <a:spcBef>
           <a:spcPts val="500"/>
         </a:spcBef>
-        <a:buFont typeface="Arial" panose="020B0604020202020204" pitchFamily="34" charset="0"/>
+        <a:buFont typeface="Arial" panose="020b0604020202020204" pitchFamily="34" charset="0"/>
         <a:buChar char="•"/>
         <a:defRPr sz="1800" kern="1200">
           <a:solidFill>
@@ -3680,7 +3661,7 @@
         <a:spcBef>
           <a:spcPts val="500"/>
         </a:spcBef>
-        <a:buFont typeface="Arial" panose="020B0604020202020204" pitchFamily="34" charset="0"/>
+        <a:buFont typeface="Arial" panose="020b0604020202020204" pitchFamily="34" charset="0"/>
         <a:buChar char="•"/>
         <a:defRPr sz="1800" kern="1200">
           <a:solidFill>
@@ -3698,7 +3679,7 @@
         <a:spcBef>
           <a:spcPts val="500"/>
         </a:spcBef>
-        <a:buFont typeface="Arial" panose="020B0604020202020204" pitchFamily="34" charset="0"/>
+        <a:buFont typeface="Arial" panose="020b0604020202020204" pitchFamily="34" charset="0"/>
         <a:buChar char="•"/>
         <a:defRPr sz="1800" kern="1200">
           <a:solidFill>
@@ -3716,7 +3697,7 @@
         <a:spcBef>
           <a:spcPts val="500"/>
         </a:spcBef>
-        <a:buFont typeface="Arial" panose="020B0604020202020204" pitchFamily="34" charset="0"/>
+        <a:buFont typeface="Arial" panose="020b0604020202020204" pitchFamily="34" charset="0"/>
         <a:buChar char="•"/>
         <a:defRPr sz="1800" kern="1200">
           <a:solidFill>
@@ -3828,8 +3809,8 @@
 </file>
 
 <file path=ppt/slides/slide1.xml><?xml version="1.0" encoding="utf-8"?>
-<p:sld xmlns:a="http://schemas.openxmlformats.org/drawingml/2006/main" xmlns:r="http://schemas.openxmlformats.org/officeDocument/2006/relationships" xmlns:p="http://schemas.openxmlformats.org/presentationml/2006/main">
-  <p:cSld>
+<p:sld xmlns:a="http://schemas.openxmlformats.org/drawingml/2006/main" xmlns:r="http://schemas.openxmlformats.org/officeDocument/2006/relationships" xmlns:m="http://schemas.openxmlformats.org/officeDocument/2006/math" xmlns:w="http://schemas.openxmlformats.org/wordprocessingml/2006/main" xmlns:wp="http://schemas.openxmlformats.org/drawingml/2006/wordprocessingDrawing" xmlns:a14="http://schemas.microsoft.com/office/drawing/2010/main" xmlns:mc="http://schemas.openxmlformats.org/markup-compatibility/2006" xmlns:p14="http://schemas.microsoft.com/office/powerpoint/2010/main" xmlns:p15="http://schemas.microsoft.com/office/powerpoint/2012/main" xmlns:p159="http://schemas.microsoft.com/office/powerpoint/2015/09/main" xmlns:p="http://schemas.openxmlformats.org/presentationml/2006/main">
+  <p:cSld name="">
     <p:spTree>
       <p:nvGrpSpPr>
         <p:cNvPr id="1" name=""/>
@@ -3840,8 +3821,6 @@
         <a:xfrm>
           <a:off x="0" y="0"/>
           <a:ext cx="0" cy="0"/>
-          <a:chOff x="0" y="0"/>
-          <a:chExt cx="0" cy="0"/>
         </a:xfrm>
       </p:grpSpPr>
       <p:sp>
@@ -3866,14 +3845,10 @@
           <a:lstStyle/>
           <a:p>
             <a:r>
-              <a:rPr lang="de-DE" dirty="0"/>
-              <a:t>PPTX Parser </a:t>
-            </a:r>
-            <a:r>
-              <a:rPr lang="de-DE" dirty="0" err="1"/>
-              <a:t>Fixtures</a:t>
-            </a:r>
-            <a:endParaRPr lang="de-DE" dirty="0"/>
+              <a:rPr lang="de-DE"/>
+              <a:t>PPTX Parser Fixtures</a:t>
+            </a:r>
+            <a:endParaRPr lang="de-DE"/>
           </a:p>
         </p:txBody>
       </p:sp>
@@ -3904,109 +3879,71 @@
               <a:buNone/>
             </a:pPr>
             <a:r>
-              <a:rPr lang="de-DE" dirty="0"/>
-              <a:t>Plain </a:t>
-            </a:r>
-            <a:r>
-              <a:rPr lang="de-DE" dirty="0" err="1"/>
-              <a:t>paragraph</a:t>
-            </a:r>
-            <a:endParaRPr lang="de-DE" dirty="0"/>
+              <a:rPr lang="de-DE"/>
+              <a:t>Plain paragraph</a:t>
+            </a:r>
+            <a:endParaRPr lang="de-DE"/>
           </a:p>
           <a:p>
             <a:pPr marL="0" indent="0">
               <a:buNone/>
             </a:pPr>
             <a:r>
-              <a:rPr lang="de-DE" b="1" dirty="0" err="1"/>
-              <a:t>Bold</a:t>
-            </a:r>
-            <a:r>
-              <a:rPr lang="de-DE" b="1" dirty="0"/>
-              <a:t> </a:t>
-            </a:r>
-            <a:r>
-              <a:rPr lang="de-DE" b="1" dirty="0" err="1"/>
-              <a:t>text</a:t>
-            </a:r>
-            <a:endParaRPr lang="de-DE" dirty="0"/>
+              <a:rPr lang="de-DE" b="1" err="1"/>
+              <a:t>Bold text</a:t>
+            </a:r>
+            <a:endParaRPr lang="de-DE"/>
           </a:p>
           <a:p>
             <a:pPr marL="0" indent="0">
               <a:buNone/>
             </a:pPr>
             <a:r>
-              <a:rPr lang="de-DE" i="1" dirty="0"/>
-              <a:t>Italic </a:t>
-            </a:r>
-            <a:r>
-              <a:rPr lang="de-DE" i="1" dirty="0" err="1"/>
-              <a:t>text</a:t>
-            </a:r>
-            <a:endParaRPr lang="de-DE" dirty="0"/>
+              <a:rPr lang="de-DE" i="1"/>
+              <a:t>Italic text</a:t>
+            </a:r>
+            <a:endParaRPr lang="de-DE"/>
           </a:p>
           <a:p>
             <a:pPr marL="0" indent="0">
               <a:buNone/>
             </a:pPr>
             <a:r>
-              <a:rPr lang="de-DE" u="sng" dirty="0" err="1"/>
-              <a:t>Underlined</a:t>
-            </a:r>
-            <a:r>
-              <a:rPr lang="de-DE" u="sng" dirty="0"/>
-              <a:t> </a:t>
-            </a:r>
-            <a:r>
-              <a:rPr lang="de-DE" u="sng" dirty="0" err="1"/>
-              <a:t>text</a:t>
-            </a:r>
-            <a:endParaRPr lang="de-DE" dirty="0"/>
+              <a:rPr lang="de-DE" u="sng" err="1"/>
+              <a:t>Underlined text</a:t>
+            </a:r>
+            <a:endParaRPr lang="de-DE"/>
           </a:p>
           <a:p>
             <a:pPr marL="0" indent="0">
               <a:buNone/>
             </a:pPr>
             <a:r>
-              <a:rPr lang="de-DE" b="1" i="1" dirty="0" err="1"/>
-              <a:t>Bold</a:t>
-            </a:r>
-            <a:r>
-              <a:rPr lang="de-DE" b="1" i="1" dirty="0"/>
-              <a:t> and </a:t>
-            </a:r>
-            <a:r>
-              <a:rPr lang="de-DE" b="1" i="1" dirty="0" err="1"/>
-              <a:t>italic</a:t>
-            </a:r>
-            <a:r>
-              <a:rPr lang="de-DE" b="1" i="1" dirty="0"/>
-              <a:t> </a:t>
-            </a:r>
-            <a:r>
-              <a:rPr lang="de-DE" b="1" i="1" dirty="0" err="1"/>
-              <a:t>text</a:t>
-            </a:r>
-            <a:endParaRPr lang="de-DE" b="1" i="1" dirty="0"/>
+              <a:rPr lang="de-DE" b="1" i="1" err="1"/>
+              <a:t>Bold and italic text</a:t>
+            </a:r>
+            <a:endParaRPr lang="de-DE" b="1" i="1"/>
           </a:p>
         </p:txBody>
       </p:sp>
     </p:spTree>
     <p:extLst>
       <p:ext uri="{BB962C8B-B14F-4D97-AF65-F5344CB8AC3E}">
-        <p14:creationId xmlns:p14="http://schemas.microsoft.com/office/powerpoint/2010/main" val="2393947391"/>
+        <p14:creationId val="2393947391"/>
       </p:ext>
     </p:extLst>
   </p:cSld>
   <p:clrMapOvr>
     <a:masterClrMapping/>
   </p:clrMapOvr>
+  <p:transition/>
+  <p:timing/>
 </p:sld>
 </file>
 
 <file path=ppt/slides/slide2.xml><?xml version="1.0" encoding="utf-8"?>
-<p:sld xmlns:a="http://schemas.openxmlformats.org/drawingml/2006/main" xmlns:r="http://schemas.openxmlformats.org/officeDocument/2006/relationships" xmlns:p="http://schemas.openxmlformats.org/presentationml/2006/main">
-  <p:cSld>
+<p:sld xmlns:a="http://schemas.openxmlformats.org/drawingml/2006/main" xmlns:r="http://schemas.openxmlformats.org/officeDocument/2006/relationships" xmlns:m="http://schemas.openxmlformats.org/officeDocument/2006/math" xmlns:w="http://schemas.openxmlformats.org/wordprocessingml/2006/main" xmlns:wp="http://schemas.openxmlformats.org/drawingml/2006/wordprocessingDrawing" xmlns:a14="http://schemas.microsoft.com/office/drawing/2010/main" xmlns:mc="http://schemas.openxmlformats.org/markup-compatibility/2006" xmlns:p14="http://schemas.microsoft.com/office/powerpoint/2010/main" xmlns:p15="http://schemas.microsoft.com/office/powerpoint/2012/main" xmlns:p159="http://schemas.microsoft.com/office/powerpoint/2015/09/main" xmlns:p="http://schemas.openxmlformats.org/presentationml/2006/main">
+  <p:cSld name="">
     <p:spTree>
       <p:nvGrpSpPr>
         <p:cNvPr id="1" name=""/>
@@ -4017,8 +3954,6 @@
         <a:xfrm>
           <a:off x="0" y="0"/>
           <a:ext cx="0" cy="0"/>
-          <a:chOff x="0" y="0"/>
-          <a:chExt cx="0" cy="0"/>
         </a:xfrm>
       </p:grpSpPr>
       <p:sp>
@@ -4043,7 +3978,7 @@
           <a:lstStyle/>
           <a:p>
             <a:r>
-              <a:rPr lang="de-DE" dirty="0"/>
+              <a:rPr lang="de-DE"/>
               <a:t>Lists</a:t>
             </a:r>
           </a:p>
@@ -4071,62 +4006,40 @@
           <a:lstStyle/>
           <a:p>
             <a:r>
-              <a:rPr lang="de-DE" dirty="0"/>
-              <a:t>First </a:t>
-            </a:r>
-            <a:r>
-              <a:rPr lang="de-DE" dirty="0" err="1"/>
-              <a:t>bullet</a:t>
-            </a:r>
-            <a:endParaRPr lang="de-DE" dirty="0"/>
-          </a:p>
-          <a:p>
-            <a:r>
-              <a:rPr lang="de-DE" dirty="0"/>
-              <a:t>Second </a:t>
-            </a:r>
-            <a:r>
-              <a:rPr lang="de-DE" dirty="0" err="1"/>
-              <a:t>bullet</a:t>
-            </a:r>
-            <a:endParaRPr lang="de-DE" dirty="0"/>
+              <a:rPr lang="de-DE"/>
+              <a:t>First bullet</a:t>
+            </a:r>
+            <a:endParaRPr lang="de-DE"/>
+          </a:p>
+          <a:p>
+            <a:r>
+              <a:rPr lang="de-DE"/>
+              <a:t>Second bullet</a:t>
+            </a:r>
+            <a:endParaRPr lang="de-DE"/>
           </a:p>
           <a:p>
             <a:pPr lvl="1"/>
             <a:r>
-              <a:rPr lang="de-DE" dirty="0" err="1"/>
-              <a:t>Nested</a:t>
-            </a:r>
-            <a:r>
-              <a:rPr lang="de-DE" dirty="0"/>
-              <a:t> </a:t>
-            </a:r>
-            <a:r>
-              <a:rPr lang="de-DE" dirty="0" err="1"/>
-              <a:t>bullet</a:t>
-            </a:r>
-            <a:endParaRPr lang="de-DE" dirty="0"/>
-          </a:p>
-          <a:p>
-            <a:r>
-              <a:rPr lang="de-DE" dirty="0">
+              <a:rPr lang="de-DE" err="1"/>
+              <a:t>Nested bullet</a:t>
+            </a:r>
+            <a:endParaRPr lang="de-DE"/>
+          </a:p>
+          <a:p>
+            <a:r>
+              <a:rPr lang="de-DE">
                 <a:hlinkClick r:id="rId2"/>
               </a:rPr>
-              <a:t>Link </a:t>
-            </a:r>
-            <a:r>
-              <a:rPr lang="de-DE" dirty="0" err="1">
-                <a:hlinkClick r:id="rId2"/>
-              </a:rPr>
-              <a:t>bullet</a:t>
-            </a:r>
-            <a:endParaRPr lang="de-DE" dirty="0"/>
+              <a:t>Link bullet</a:t>
+            </a:r>
+            <a:endParaRPr lang="de-DE"/>
           </a:p>
           <a:p>
             <a:pPr marL="0" indent="0">
               <a:buNone/>
             </a:pPr>
-            <a:endParaRPr lang="de-DE" dirty="0"/>
+            <a:endParaRPr lang="de-DE"/>
           </a:p>
           <a:p>
             <a:pPr marL="514350" indent="-514350">
@@ -4134,14 +4047,10 @@
               <a:buAutoNum type="arabicPeriod"/>
             </a:pPr>
             <a:r>
-              <a:rPr lang="de-DE" dirty="0"/>
-              <a:t>First </a:t>
-            </a:r>
-            <a:r>
-              <a:rPr lang="de-DE" dirty="0" err="1"/>
-              <a:t>number</a:t>
-            </a:r>
-            <a:endParaRPr lang="de-DE" dirty="0"/>
+              <a:rPr lang="de-DE"/>
+              <a:t>First number</a:t>
+            </a:r>
+            <a:endParaRPr lang="de-DE"/>
           </a:p>
           <a:p>
             <a:pPr marL="514350" indent="-514350">
@@ -4149,14 +4058,10 @@
               <a:buAutoNum type="arabicPeriod"/>
             </a:pPr>
             <a:r>
-              <a:rPr lang="de-DE" dirty="0"/>
-              <a:t>Second </a:t>
-            </a:r>
-            <a:r>
-              <a:rPr lang="de-DE" dirty="0" err="1"/>
-              <a:t>number</a:t>
-            </a:r>
-            <a:endParaRPr lang="de-DE" dirty="0"/>
+              <a:rPr lang="de-DE"/>
+              <a:t>Second number</a:t>
+            </a:r>
+            <a:endParaRPr lang="de-DE"/>
           </a:p>
           <a:p>
             <a:pPr marL="971550" lvl="1" indent="-514350">
@@ -4164,37 +4069,31 @@
               <a:buAutoNum type="arabicPeriod"/>
             </a:pPr>
             <a:r>
-              <a:rPr lang="de-DE" dirty="0" err="1"/>
-              <a:t>Nested</a:t>
-            </a:r>
-            <a:r>
-              <a:rPr lang="de-DE" dirty="0"/>
-              <a:t> </a:t>
-            </a:r>
-            <a:r>
-              <a:rPr lang="de-DE" dirty="0" err="1"/>
-              <a:t>number</a:t>
-            </a:r>
-            <a:endParaRPr lang="de-DE" dirty="0"/>
+              <a:rPr lang="de-DE" err="1"/>
+              <a:t>Nested number</a:t>
+            </a:r>
+            <a:endParaRPr lang="de-DE"/>
           </a:p>
         </p:txBody>
       </p:sp>
     </p:spTree>
     <p:extLst>
       <p:ext uri="{BB962C8B-B14F-4D97-AF65-F5344CB8AC3E}">
-        <p14:creationId xmlns:p14="http://schemas.microsoft.com/office/powerpoint/2010/main" val="3531872515"/>
+        <p14:creationId val="3531872515"/>
       </p:ext>
     </p:extLst>
   </p:cSld>
   <p:clrMapOvr>
     <a:masterClrMapping/>
   </p:clrMapOvr>
+  <p:transition/>
+  <p:timing/>
 </p:sld>
 </file>
 
 <file path=ppt/slides/slide3.xml><?xml version="1.0" encoding="utf-8"?>
-<p:sld xmlns:a="http://schemas.openxmlformats.org/drawingml/2006/main" xmlns:r="http://schemas.openxmlformats.org/officeDocument/2006/relationships" xmlns:p="http://schemas.openxmlformats.org/presentationml/2006/main">
-  <p:cSld>
+<p:sld xmlns:a="http://schemas.openxmlformats.org/drawingml/2006/main" xmlns:r="http://schemas.openxmlformats.org/officeDocument/2006/relationships" xmlns:m="http://schemas.openxmlformats.org/officeDocument/2006/math" xmlns:w="http://schemas.openxmlformats.org/wordprocessingml/2006/main" xmlns:wp="http://schemas.openxmlformats.org/drawingml/2006/wordprocessingDrawing" xmlns:a14="http://schemas.microsoft.com/office/drawing/2010/main" xmlns:mc="http://schemas.openxmlformats.org/markup-compatibility/2006" xmlns:p14="http://schemas.microsoft.com/office/powerpoint/2010/main" xmlns:p15="http://schemas.microsoft.com/office/powerpoint/2012/main" xmlns:p159="http://schemas.microsoft.com/office/powerpoint/2015/09/main" xmlns:p="http://schemas.openxmlformats.org/presentationml/2006/main">
+  <p:cSld name="">
     <p:spTree>
       <p:nvGrpSpPr>
         <p:cNvPr id="1" name=""/>
@@ -4205,8 +4104,6 @@
         <a:xfrm>
           <a:off x="0" y="0"/>
           <a:ext cx="0" cy="0"/>
-          <a:chOff x="0" y="0"/>
-          <a:chExt cx="0" cy="0"/>
         </a:xfrm>
       </p:grpSpPr>
       <p:sp>
@@ -4231,7 +4128,7 @@
           <a:lstStyle/>
           <a:p>
             <a:r>
-              <a:rPr lang="de-DE" dirty="0"/>
+              <a:rPr lang="de-DE"/>
               <a:t>Tables</a:t>
             </a:r>
           </a:p>
@@ -4253,7 +4150,7 @@
             <p:ph idx="1"/>
             <p:extLst>
               <p:ext uri="{D42A27DB-BD31-4B8C-83A1-F6EECF244321}">
-                <p14:modId xmlns:p14="http://schemas.microsoft.com/office/powerpoint/2010/main" val="2661539675"/>
+                <p14:modId val="2661539675"/>
               </p:ext>
             </p:extLst>
           </p:nvPr>
@@ -4294,11 +4191,11 @@
               <a:tr h="370840">
                 <a:tc>
                   <a:txBody>
-                    <a:bodyPr/>
+                    <a:bodyPr vert="horz" wrap="square"/>
                     <a:lstStyle/>
                     <a:p>
                       <a:r>
-                        <a:rPr lang="de-DE" dirty="0"/>
+                        <a:rPr lang="de-DE"/>
                         <a:t>Heading A</a:t>
                       </a:r>
                     </a:p>
@@ -4307,11 +4204,11 @@
                 </a:tc>
                 <a:tc>
                   <a:txBody>
-                    <a:bodyPr/>
+                    <a:bodyPr vert="horz" wrap="square"/>
                     <a:lstStyle/>
                     <a:p>
                       <a:r>
-                        <a:rPr lang="de-DE" dirty="0"/>
+                        <a:rPr lang="de-DE"/>
                         <a:t>Heading B</a:t>
                       </a:r>
                     </a:p>
@@ -4320,11 +4217,11 @@
                 </a:tc>
                 <a:tc>
                   <a:txBody>
-                    <a:bodyPr/>
+                    <a:bodyPr vert="horz" wrap="square"/>
                     <a:lstStyle/>
                     <a:p>
                       <a:r>
-                        <a:rPr lang="de-DE" dirty="0"/>
+                        <a:rPr lang="de-DE"/>
                         <a:t>Heading C</a:t>
                       </a:r>
                     </a:p>
@@ -4340,11 +4237,11 @@
               <a:tr h="370840">
                 <a:tc>
                   <a:txBody>
-                    <a:bodyPr/>
+                    <a:bodyPr vert="horz" wrap="square"/>
                     <a:lstStyle/>
                     <a:p>
                       <a:r>
-                        <a:rPr lang="de-DE" dirty="0"/>
+                        <a:rPr lang="de-DE"/>
                         <a:t>A1</a:t>
                       </a:r>
                     </a:p>
@@ -4353,11 +4250,11 @@
                 </a:tc>
                 <a:tc>
                   <a:txBody>
-                    <a:bodyPr/>
+                    <a:bodyPr vert="horz" wrap="square"/>
                     <a:lstStyle/>
                     <a:p>
                       <a:r>
-                        <a:rPr lang="de-DE" dirty="0"/>
+                        <a:rPr lang="de-DE"/>
                         <a:t>B1</a:t>
                       </a:r>
                     </a:p>
@@ -4366,11 +4263,11 @@
                 </a:tc>
                 <a:tc>
                   <a:txBody>
-                    <a:bodyPr/>
+                    <a:bodyPr vert="horz" wrap="square"/>
                     <a:lstStyle/>
                     <a:p>
                       <a:r>
-                        <a:rPr lang="de-DE" dirty="0"/>
+                        <a:rPr lang="de-DE"/>
                         <a:t>C1</a:t>
                       </a:r>
                     </a:p>
@@ -4386,11 +4283,11 @@
               <a:tr h="370840">
                 <a:tc>
                   <a:txBody>
-                    <a:bodyPr/>
+                    <a:bodyPr vert="horz" wrap="square"/>
                     <a:lstStyle/>
                     <a:p>
                       <a:r>
-                        <a:rPr lang="de-DE" dirty="0"/>
+                        <a:rPr lang="de-DE"/>
                         <a:t>A2</a:t>
                       </a:r>
                     </a:p>
@@ -4399,11 +4296,11 @@
                 </a:tc>
                 <a:tc>
                   <a:txBody>
-                    <a:bodyPr/>
+                    <a:bodyPr vert="horz" wrap="square"/>
                     <a:lstStyle/>
                     <a:p>
                       <a:r>
-                        <a:rPr lang="de-DE" dirty="0"/>
+                        <a:rPr lang="de-DE"/>
                         <a:t>B2</a:t>
                       </a:r>
                     </a:p>
@@ -4412,16 +4309,16 @@
                 </a:tc>
                 <a:tc>
                   <a:txBody>
-                    <a:bodyPr/>
+                    <a:bodyPr vert="horz" wrap="square"/>
                     <a:lstStyle/>
                     <a:p>
                       <a:r>
-                        <a:rPr lang="de-DE" dirty="0">
+                        <a:rPr lang="de-DE">
                           <a:hlinkClick r:id="rId2"/>
                         </a:rPr>
                         <a:t>C2</a:t>
                       </a:r>
-                      <a:endParaRPr lang="de-DE" dirty="0"/>
+                      <a:endParaRPr lang="de-DE"/>
                     </a:p>
                   </a:txBody>
                   <a:tcPr/>
@@ -4439,19 +4336,21 @@
     </p:spTree>
     <p:extLst>
       <p:ext uri="{BB962C8B-B14F-4D97-AF65-F5344CB8AC3E}">
-        <p14:creationId xmlns:p14="http://schemas.microsoft.com/office/powerpoint/2010/main" val="3336043516"/>
+        <p14:creationId val="3336043516"/>
       </p:ext>
     </p:extLst>
   </p:cSld>
   <p:clrMapOvr>
     <a:masterClrMapping/>
   </p:clrMapOvr>
+  <p:transition/>
+  <p:timing/>
 </p:sld>
 </file>
 
 <file path=ppt/slides/slide4.xml><?xml version="1.0" encoding="utf-8"?>
-<p:sld xmlns:a="http://schemas.openxmlformats.org/drawingml/2006/main" xmlns:r="http://schemas.openxmlformats.org/officeDocument/2006/relationships" xmlns:p="http://schemas.openxmlformats.org/presentationml/2006/main">
-  <p:cSld>
+<p:sld xmlns:a="http://schemas.openxmlformats.org/drawingml/2006/main" xmlns:r="http://schemas.openxmlformats.org/officeDocument/2006/relationships" xmlns:m="http://schemas.openxmlformats.org/officeDocument/2006/math" xmlns:w="http://schemas.openxmlformats.org/wordprocessingml/2006/main" xmlns:wp="http://schemas.openxmlformats.org/drawingml/2006/wordprocessingDrawing" xmlns:a14="http://schemas.microsoft.com/office/drawing/2010/main" xmlns:mc="http://schemas.openxmlformats.org/markup-compatibility/2006" xmlns:p14="http://schemas.microsoft.com/office/powerpoint/2010/main" xmlns:p15="http://schemas.microsoft.com/office/powerpoint/2012/main" xmlns:p159="http://schemas.microsoft.com/office/powerpoint/2015/09/main" xmlns:p="http://schemas.openxmlformats.org/presentationml/2006/main">
+  <p:cSld name="">
     <p:spTree>
       <p:nvGrpSpPr>
         <p:cNvPr id="1" name=""/>
@@ -4462,8 +4361,6 @@
         <a:xfrm>
           <a:off x="0" y="0"/>
           <a:ext cx="0" cy="0"/>
-          <a:chOff x="0" y="0"/>
-          <a:chExt cx="0" cy="0"/>
         </a:xfrm>
       </p:grpSpPr>
       <p:sp>
@@ -4488,18 +4385,10 @@
           <a:lstStyle/>
           <a:p>
             <a:r>
-              <a:rPr lang="de-DE" dirty="0" err="1"/>
-              <a:t>Grouped</a:t>
-            </a:r>
-            <a:r>
-              <a:rPr lang="de-DE" dirty="0"/>
-              <a:t> </a:t>
-            </a:r>
-            <a:r>
-              <a:rPr lang="de-DE" dirty="0" err="1"/>
-              <a:t>elements</a:t>
-            </a:r>
-            <a:endParaRPr lang="de-DE" dirty="0"/>
+              <a:rPr lang="de-DE" err="1"/>
+              <a:t>Grouped elements</a:t>
+            </a:r>
+            <a:endParaRPr lang="de-DE"/>
           </a:p>
         </p:txBody>
       </p:sp>
@@ -4552,12 +4441,8 @@
             <a:lstStyle/>
             <a:p>
               <a:r>
-                <a:rPr lang="de-DE" sz="2800" b="1" dirty="0" err="1"/>
-                <a:t>Grouped</a:t>
-              </a:r>
-              <a:r>
-                <a:rPr lang="de-DE" sz="2800" b="1" dirty="0"/>
-                <a:t> Heading</a:t>
+                <a:rPr lang="de-DE" sz="2800" b="1" err="1"/>
+                <a:t>Grouped Heading</a:t>
               </a:r>
             </a:p>
           </p:txBody>
@@ -4591,12 +4476,8 @@
             <a:lstStyle/>
             <a:p>
               <a:r>
-                <a:rPr lang="de-DE" dirty="0" err="1"/>
-                <a:t>Grouped</a:t>
-              </a:r>
-              <a:r>
-                <a:rPr lang="de-DE" dirty="0"/>
-                <a:t> Body</a:t>
+                <a:rPr lang="de-DE" err="1"/>
+                <a:t>Grouped Body</a:t>
               </a:r>
             </a:p>
           </p:txBody>
@@ -4605,19 +4486,21 @@
     </p:spTree>
     <p:extLst>
       <p:ext uri="{BB962C8B-B14F-4D97-AF65-F5344CB8AC3E}">
-        <p14:creationId xmlns:p14="http://schemas.microsoft.com/office/powerpoint/2010/main" val="4105507018"/>
+        <p14:creationId val="4105507018"/>
       </p:ext>
     </p:extLst>
   </p:cSld>
   <p:clrMapOvr>
     <a:masterClrMapping/>
   </p:clrMapOvr>
+  <p:transition/>
+  <p:timing/>
 </p:sld>
 </file>
 
 <file path=ppt/slides/slide5.xml><?xml version="1.0" encoding="utf-8"?>
-<p:sld xmlns:a="http://schemas.openxmlformats.org/drawingml/2006/main" xmlns:r="http://schemas.openxmlformats.org/officeDocument/2006/relationships" xmlns:p="http://schemas.openxmlformats.org/presentationml/2006/main">
-  <p:cSld>
+<p:sld xmlns:a="http://schemas.openxmlformats.org/drawingml/2006/main" xmlns:r="http://schemas.openxmlformats.org/officeDocument/2006/relationships" xmlns:m="http://schemas.openxmlformats.org/officeDocument/2006/math" xmlns:w="http://schemas.openxmlformats.org/wordprocessingml/2006/main" xmlns:wp="http://schemas.openxmlformats.org/drawingml/2006/wordprocessingDrawing" xmlns:a14="http://schemas.microsoft.com/office/drawing/2010/main" xmlns:mc="http://schemas.openxmlformats.org/markup-compatibility/2006" xmlns:p14="http://schemas.microsoft.com/office/powerpoint/2010/main" xmlns:p15="http://schemas.microsoft.com/office/powerpoint/2012/main" xmlns:p159="http://schemas.microsoft.com/office/powerpoint/2015/09/main" xmlns:p="http://schemas.openxmlformats.org/presentationml/2006/main">
+  <p:cSld name="">
     <p:spTree>
       <p:nvGrpSpPr>
         <p:cNvPr id="1" name=""/>
@@ -4628,8 +4511,6 @@
         <a:xfrm>
           <a:off x="0" y="0"/>
           <a:ext cx="0" cy="0"/>
-          <a:chOff x="0" y="0"/>
-          <a:chExt cx="0" cy="0"/>
         </a:xfrm>
       </p:grpSpPr>
       <p:sp>
@@ -4654,29 +4535,13 @@
           <a:lstStyle/>
           <a:p>
             <a:r>
-              <a:rPr lang="de-DE" dirty="0" err="1"/>
-              <a:t>Sorting</a:t>
-            </a:r>
-            <a:r>
-              <a:rPr lang="de-DE" dirty="0"/>
-              <a:t> and </a:t>
-            </a:r>
-            <a:r>
-              <a:rPr lang="de-DE" dirty="0" err="1"/>
-              <a:t>empty</a:t>
-            </a:r>
-            <a:r>
-              <a:rPr lang="de-DE" dirty="0"/>
-              <a:t> </a:t>
-            </a:r>
-            <a:r>
-              <a:rPr lang="de-DE" dirty="0" err="1"/>
-              <a:t>content</a:t>
+              <a:rPr lang="de-DE" err="1"/>
+              <a:t>Sorting and empty content</a:t>
             </a:r>
             <a:br>
-              <a:rPr lang="de-DE" dirty="0"/>
+              <a:rPr lang="de-DE" err="1"/>
             </a:br>
-            <a:endParaRPr lang="de-DE" dirty="0"/>
+            <a:endParaRPr lang="de-DE"/>
           </a:p>
         </p:txBody>
       </p:sp>
@@ -4709,7 +4574,7 @@
           <a:lstStyle/>
           <a:p>
             <a:r>
-              <a:rPr lang="de-DE" dirty="0"/>
+              <a:rPr lang="de-DE"/>
               <a:t>First</a:t>
             </a:r>
           </a:p>
@@ -4744,7 +4609,7 @@
           <a:lstStyle/>
           <a:p>
             <a:r>
-              <a:rPr lang="de-DE" dirty="0"/>
+              <a:rPr lang="de-DE"/>
               <a:t>Second</a:t>
             </a:r>
           </a:p>
@@ -4779,7 +4644,7 @@
           <a:lstStyle/>
           <a:p>
             <a:r>
-              <a:rPr lang="de-DE" dirty="0"/>
+              <a:rPr lang="de-DE"/>
               <a:t>Third</a:t>
             </a:r>
           </a:p>
@@ -4800,7 +4665,7 @@
           <p:nvPr>
             <p:extLst>
               <p:ext uri="{D42A27DB-BD31-4B8C-83A1-F6EECF244321}">
-                <p14:modId xmlns:p14="http://schemas.microsoft.com/office/powerpoint/2010/main" val="1082573945"/>
+                <p14:modId val="1082573945"/>
               </p:ext>
             </p:extLst>
           </p:nvPr>
@@ -4841,11 +4706,11 @@
               <a:tr h="370840">
                 <a:tc>
                   <a:txBody>
-                    <a:bodyPr/>
+                    <a:bodyPr vert="horz" wrap="square"/>
                     <a:lstStyle/>
                     <a:p>
                       <a:r>
-                        <a:rPr lang="de-DE" dirty="0"/>
+                        <a:rPr lang="de-DE"/>
                         <a:t>Left</a:t>
                       </a:r>
                     </a:p>
@@ -4854,21 +4719,21 @@
                 </a:tc>
                 <a:tc>
                   <a:txBody>
-                    <a:bodyPr/>
+                    <a:bodyPr vert="horz" wrap="square"/>
                     <a:lstStyle/>
                     <a:p>
-                      <a:endParaRPr lang="de-DE" dirty="0"/>
+                      <a:endParaRPr lang="de-DE"/>
                     </a:p>
                   </a:txBody>
                   <a:tcPr/>
                 </a:tc>
                 <a:tc>
                   <a:txBody>
-                    <a:bodyPr/>
+                    <a:bodyPr vert="horz" wrap="square"/>
                     <a:lstStyle/>
                     <a:p>
                       <a:r>
-                        <a:rPr lang="de-DE" dirty="0"/>
+                        <a:rPr lang="de-DE"/>
                         <a:t>Right</a:t>
                       </a:r>
                     </a:p>
@@ -4884,21 +4749,21 @@
               <a:tr h="370840">
                 <a:tc>
                   <a:txBody>
-                    <a:bodyPr/>
+                    <a:bodyPr vert="horz" wrap="square"/>
                     <a:lstStyle/>
                     <a:p>
-                      <a:endParaRPr lang="de-DE" dirty="0"/>
+                      <a:endParaRPr lang="de-DE"/>
                     </a:p>
                   </a:txBody>
                   <a:tcPr/>
                 </a:tc>
                 <a:tc>
                   <a:txBody>
-                    <a:bodyPr/>
+                    <a:bodyPr vert="horz" wrap="square"/>
                     <a:lstStyle/>
                     <a:p>
                       <a:r>
-                        <a:rPr lang="de-DE" dirty="0"/>
+                        <a:rPr lang="de-DE"/>
                         <a:t>Middle</a:t>
                       </a:r>
                     </a:p>
@@ -4907,10 +4772,10 @@
                 </a:tc>
                 <a:tc>
                   <a:txBody>
-                    <a:bodyPr/>
+                    <a:bodyPr vert="horz" wrap="square"/>
                     <a:lstStyle/>
                     <a:p>
-                      <a:endParaRPr lang="de-DE" dirty="0"/>
+                      <a:endParaRPr lang="de-DE"/>
                     </a:p>
                   </a:txBody>
                   <a:tcPr/>
@@ -4928,19 +4793,21 @@
     </p:spTree>
     <p:extLst>
       <p:ext uri="{BB962C8B-B14F-4D97-AF65-F5344CB8AC3E}">
-        <p14:creationId xmlns:p14="http://schemas.microsoft.com/office/powerpoint/2010/main" val="111276283"/>
+        <p14:creationId val="111276283"/>
       </p:ext>
     </p:extLst>
   </p:cSld>
   <p:clrMapOvr>
     <a:masterClrMapping/>
   </p:clrMapOvr>
+  <p:transition/>
+  <p:timing/>
 </p:sld>
 </file>
 
 <file path=ppt/slides/slide6.xml><?xml version="1.0" encoding="utf-8"?>
-<p:sld xmlns:a="http://schemas.openxmlformats.org/drawingml/2006/main" xmlns:r="http://schemas.openxmlformats.org/officeDocument/2006/relationships" xmlns:p="http://schemas.openxmlformats.org/presentationml/2006/main">
-  <p:cSld>
+<p:sld xmlns:a="http://schemas.openxmlformats.org/drawingml/2006/main" xmlns:r="http://schemas.openxmlformats.org/officeDocument/2006/relationships" xmlns:m="http://schemas.openxmlformats.org/officeDocument/2006/math" xmlns:w="http://schemas.openxmlformats.org/wordprocessingml/2006/main" xmlns:wp="http://schemas.openxmlformats.org/drawingml/2006/wordprocessingDrawing" xmlns:a14="http://schemas.microsoft.com/office/drawing/2010/main" xmlns:mc="http://schemas.openxmlformats.org/markup-compatibility/2006" xmlns:p14="http://schemas.microsoft.com/office/powerpoint/2010/main" xmlns:p15="http://schemas.microsoft.com/office/powerpoint/2012/main" xmlns:p159="http://schemas.microsoft.com/office/powerpoint/2015/09/main" xmlns:p="http://schemas.openxmlformats.org/presentationml/2006/main">
+  <p:cSld name="">
     <p:spTree>
       <p:nvGrpSpPr>
         <p:cNvPr id="1" name=""/>
@@ -4951,20 +4818,20 @@
         <a:xfrm>
           <a:off x="0" y="0"/>
           <a:ext cx="0" cy="0"/>
-          <a:chOff x="0" y="0"/>
-          <a:chExt cx="0" cy="0"/>
         </a:xfrm>
       </p:grpSpPr>
     </p:spTree>
     <p:extLst>
       <p:ext uri="{BB962C8B-B14F-4D97-AF65-F5344CB8AC3E}">
-        <p14:creationId xmlns:p14="http://schemas.microsoft.com/office/powerpoint/2010/main" val="4010986668"/>
+        <p14:creationId val="4010986668"/>
       </p:ext>
     </p:extLst>
   </p:cSld>
   <p:clrMapOvr>
     <a:masterClrMapping/>
   </p:clrMapOvr>
+  <p:transition/>
+  <p:timing/>
   <p:extLst>
     <p:ext uri="{6950BFC3-D8DA-4A85-94F7-54DA5524770B}">
       <p188:commentRel xmlns:p188="http://schemas.microsoft.com/office/powerpoint/2018/8/main" r:id="rId3"/>
@@ -4974,8 +4841,8 @@
 </file>
 
 <file path=ppt/slides/slide7.xml><?xml version="1.0" encoding="utf-8"?>
-<p:sld xmlns:a="http://schemas.openxmlformats.org/drawingml/2006/main" xmlns:r="http://schemas.openxmlformats.org/officeDocument/2006/relationships" xmlns:p="http://schemas.openxmlformats.org/presentationml/2006/main">
-  <p:cSld>
+<p:sld xmlns:a="http://schemas.openxmlformats.org/drawingml/2006/main" xmlns:r="http://schemas.openxmlformats.org/officeDocument/2006/relationships" xmlns:m="http://schemas.openxmlformats.org/officeDocument/2006/math" xmlns:w="http://schemas.openxmlformats.org/wordprocessingml/2006/main" xmlns:wp="http://schemas.openxmlformats.org/drawingml/2006/wordprocessingDrawing" xmlns:a14="http://schemas.microsoft.com/office/drawing/2010/main" xmlns:mc="http://schemas.openxmlformats.org/markup-compatibility/2006" xmlns:p14="http://schemas.microsoft.com/office/powerpoint/2010/main" xmlns:p15="http://schemas.microsoft.com/office/powerpoint/2012/main" xmlns:p159="http://schemas.microsoft.com/office/powerpoint/2015/09/main" xmlns:p="http://schemas.openxmlformats.org/presentationml/2006/main">
+  <p:cSld name="">
     <p:bg>
       <p:bgPr>
         <a:solidFill>
@@ -4994,8 +4861,6 @@
         <a:xfrm>
           <a:off x="0" y="0"/>
           <a:ext cx="0" cy="0"/>
-          <a:chOff x="0" y="0"/>
-          <a:chExt cx="0" cy="0"/>
         </a:xfrm>
       </p:grpSpPr>
       <p:sp useBgFill="1">
@@ -5126,10 +4991,6 @@
             <a:ext cx="5962785" cy="6857990"/>
           </a:xfrm>
           <a:custGeom>
-            <a:avLst/>
-            <a:gdLst/>
-            <a:ahLst/>
-            <a:cxnLst/>
             <a:rect l="l" t="t" r="r" b="b"/>
             <a:pathLst>
               <a:path w="5962785" h="6858000">
@@ -5597,18 +5458,30 @@
     </p:spTree>
     <p:extLst>
       <p:ext uri="{BB962C8B-B14F-4D97-AF65-F5344CB8AC3E}">
-        <p14:creationId xmlns:p14="http://schemas.microsoft.com/office/powerpoint/2010/main" val="3792638814"/>
+        <p14:creationId val="3792638814"/>
       </p:ext>
     </p:extLst>
   </p:cSld>
   <p:clrMapOvr>
     <a:masterClrMapping/>
   </p:clrMapOvr>
+  <p:transition/>
+  <p:timing/>
 </p:sld>
 </file>
 
+<file path=ppt/tags/tag1.xml><?xml version="1.0" encoding="utf-8"?>
+<p:tagLst xmlns:p="http://schemas.openxmlformats.org/presentationml/2006/main">
+  <p:tag name="AS_NET" val="6.0.36"/>
+  <p:tag name="AS_OS" val="Unix 6.8.0.107"/>
+  <p:tag name="AS_RELEASE_DATE" val="2024.12.14"/>
+  <p:tag name="AS_TITLE" val="Aspose.Slides for .NET Standard 2.0"/>
+  <p:tag name="AS_VERSION" val="24.12"/>
+</p:tagLst>
+</file>
+
 <file path=ppt/theme/theme1.xml><?xml version="1.0" encoding="utf-8"?>
-<a:theme xmlns:a="http://schemas.openxmlformats.org/drawingml/2006/main" name="Office">
+<a:theme xmlns:r="http://schemas.openxmlformats.org/officeDocument/2006/relationships" xmlns:a="http://schemas.openxmlformats.org/drawingml/2006/main" name="Office">
   <a:themeElements>
     <a:clrScheme name="Office">
       <a:dk1>
@@ -5651,8 +5524,8 @@
     <a:fontScheme name="Office">
       <a:majorFont>
         <a:latin typeface="Aptos Display" panose="02110004020202020204"/>
-        <a:ea typeface=""/>
-        <a:cs typeface=""/>
+        <a:ea typeface="Aptos Display" panose="02110004020202020204"/>
+        <a:cs typeface="Arial"/>
         <a:font script="Jpan" typeface="游ゴシック Light"/>
         <a:font script="Hang" typeface="맑은 고딕"/>
         <a:font script="Hans" typeface="等线 Light"/>
@@ -5703,8 +5576,8 @@
       </a:majorFont>
       <a:minorFont>
         <a:latin typeface="Aptos" panose="02110004020202020204"/>
-        <a:ea typeface=""/>
-        <a:cs typeface=""/>
+        <a:ea typeface="Aptos" panose="02110004020202020204"/>
+        <a:cs typeface="Arial"/>
         <a:font script="Jpan" typeface="游ゴシック"/>
         <a:font script="Hang" typeface="맑은 고딕"/>
         <a:font script="Hans" typeface="等线"/>
@@ -5913,7 +5786,6 @@
       </a:style>
     </a:lnDef>
   </a:objectDefaults>
-  <a:extraClrSchemeLst/>
   <a:extLst>
     <a:ext uri="{05A4C25C-085E-4340-85A3-A5531E510DB2}">
       <thm15:themeFamily xmlns:thm15="http://schemas.microsoft.com/office/thememl/2012/main" name="Office Theme" id="{2E142A2C-CD16-42D6-873A-C26D2A0506FA}" vid="{1BDDFF52-6CD6-40A5-AB3C-68EB2F1E4D0A}"/>
@@ -5923,7 +5795,7 @@
 </file>
 
 <file path=ppt/theme/theme2.xml><?xml version="1.0" encoding="utf-8"?>
-<a:theme xmlns:a="http://schemas.openxmlformats.org/drawingml/2006/main" name="Office">
+<a:theme xmlns:r="http://schemas.openxmlformats.org/officeDocument/2006/relationships" xmlns:a="http://schemas.openxmlformats.org/drawingml/2006/main" name="Office">
   <a:themeElements>
     <a:clrScheme name="Office">
       <a:dk1>
@@ -5966,8 +5838,8 @@
     <a:fontScheme name="Office">
       <a:majorFont>
         <a:latin typeface="Aptos Display" panose="02110004020202020204"/>
-        <a:ea typeface=""/>
-        <a:cs typeface=""/>
+        <a:ea typeface="Aptos Display" panose="02110004020202020204"/>
+        <a:cs typeface="Arial"/>
         <a:font script="Jpan" typeface="游ゴシック Light"/>
         <a:font script="Hang" typeface="맑은 고딕"/>
         <a:font script="Hans" typeface="等线 Light"/>
@@ -6018,8 +5890,8 @@
       </a:majorFont>
       <a:minorFont>
         <a:latin typeface="Aptos" panose="02110004020202020204"/>
-        <a:ea typeface=""/>
-        <a:cs typeface=""/>
+        <a:ea typeface="Aptos" panose="02110004020202020204"/>
+        <a:cs typeface="Arial"/>
         <a:font script="Jpan" typeface="游ゴシック"/>
         <a:font script="Hang" typeface="맑은 고딕"/>
         <a:font script="Hans" typeface="等线"/>
@@ -6078,6 +5950,55 @@
           <a:gsLst>
             <a:gs pos="0">
               <a:schemeClr val="phClr">
+                <a:tint val="50000"/>
+                <a:satMod val="300000"/>
+              </a:schemeClr>
+            </a:gs>
+            <a:gs pos="35000">
+              <a:schemeClr val="phClr">
+                <a:tint val="37000"/>
+                <a:satMod val="300000"/>
+              </a:schemeClr>
+            </a:gs>
+            <a:gs pos="100000">
+              <a:schemeClr val="phClr">
+                <a:tint val="15000"/>
+                <a:satMod val="350000"/>
+              </a:schemeClr>
+            </a:gs>
+          </a:gsLst>
+          <a:lin ang="16200000" scaled="1"/>
+        </a:gradFill>
+        <a:gradFill rotWithShape="1">
+          <a:gsLst>
+            <a:gs pos="0">
+              <a:schemeClr val="phClr">
+                <a:shade val="51000"/>
+                <a:satMod val="130000"/>
+              </a:schemeClr>
+            </a:gs>
+            <a:gs pos="80000">
+              <a:schemeClr val="phClr">
+                <a:shade val="93000"/>
+                <a:satMod val="130000"/>
+              </a:schemeClr>
+            </a:gs>
+            <a:gs pos="100000">
+              <a:schemeClr val="phClr">
+                <a:shade val="94000"/>
+                <a:satMod val="135000"/>
+              </a:schemeClr>
+            </a:gs>
+          </a:gsLst>
+          <a:lin ang="16200000" scaled="0"/>
+        </a:gradFill>
+        <a:solidFill>
+          <a:schemeClr val="phClr"/>
+        </a:solidFill>
+        <a:gradFill rotWithShape="1">
+          <a:gsLst>
+            <a:gs pos="0">
+              <a:schemeClr val="phClr">
                 <a:lumMod val="110000"/>
                 <a:satMod val="105000"/>
                 <a:tint val="67000"/>
@@ -6128,6 +6049,27 @@
         </a:gradFill>
       </a:fillStyleLst>
       <a:lnStyleLst>
+        <a:ln w="9525" cap="flat" cmpd="sng" algn="ctr">
+          <a:solidFill>
+            <a:schemeClr val="phClr">
+              <a:shade val="95000"/>
+              <a:satMod val="105000"/>
+            </a:schemeClr>
+          </a:solidFill>
+          <a:prstDash val="solid"/>
+        </a:ln>
+        <a:ln w="25400" cap="flat" cmpd="sng" algn="ctr">
+          <a:solidFill>
+            <a:schemeClr val="phClr"/>
+          </a:solidFill>
+          <a:prstDash val="solid"/>
+        </a:ln>
+        <a:ln w="38100" cap="flat" cmpd="sng" algn="ctr">
+          <a:solidFill>
+            <a:schemeClr val="phClr"/>
+          </a:solidFill>
+          <a:prstDash val="solid"/>
+        </a:ln>
         <a:ln w="12700" cap="flat" cmpd="sng" algn="ctr">
           <a:solidFill>
             <a:schemeClr val="phClr"/>
@@ -6152,6 +6094,44 @@
       </a:lnStyleLst>
       <a:effectStyleLst>
         <a:effectStyle>
+          <a:effectLst>
+            <a:outerShdw blurRad="40000" dist="20000" dir="5400000" rotWithShape="0">
+              <a:srgbClr val="000000">
+                <a:alpha val="38000"/>
+              </a:srgbClr>
+            </a:outerShdw>
+          </a:effectLst>
+        </a:effectStyle>
+        <a:effectStyle>
+          <a:effectLst>
+            <a:outerShdw blurRad="40000" dist="23000" dir="5400000" rotWithShape="0">
+              <a:srgbClr val="000000">
+                <a:alpha val="35000"/>
+              </a:srgbClr>
+            </a:outerShdw>
+          </a:effectLst>
+        </a:effectStyle>
+        <a:effectStyle>
+          <a:effectLst>
+            <a:outerShdw blurRad="40000" dist="23000" dir="5400000" rotWithShape="0">
+              <a:srgbClr val="000000">
+                <a:alpha val="35000"/>
+              </a:srgbClr>
+            </a:outerShdw>
+          </a:effectLst>
+          <a:scene3d>
+            <a:camera prst="orthographicFront">
+              <a:rot lat="0" lon="0" rev="0"/>
+            </a:camera>
+            <a:lightRig rig="threePt" dir="t">
+              <a:rot lat="0" lon="0" rev="1200000"/>
+            </a:lightRig>
+          </a:scene3d>
+          <a:sp3d>
+            <a:bevelT w="63500" h="25400"/>
+          </a:sp3d>
+        </a:effectStyle>
+        <a:effectStyle>
           <a:effectLst/>
         </a:effectStyle>
         <a:effectStyle>
@@ -6168,6 +6148,54 @@
         </a:effectStyle>
       </a:effectStyleLst>
       <a:bgFillStyleLst>
+        <a:solidFill>
+          <a:schemeClr val="phClr"/>
+        </a:solidFill>
+        <a:gradFill rotWithShape="1">
+          <a:gsLst>
+            <a:gs pos="0">
+              <a:schemeClr val="phClr">
+                <a:tint val="40000"/>
+                <a:satMod val="350000"/>
+              </a:schemeClr>
+            </a:gs>
+            <a:gs pos="40000">
+              <a:schemeClr val="phClr">
+                <a:tint val="45000"/>
+                <a:shade val="99000"/>
+                <a:satMod val="350000"/>
+              </a:schemeClr>
+            </a:gs>
+            <a:gs pos="100000">
+              <a:schemeClr val="phClr">
+                <a:shade val="20000"/>
+                <a:satMod val="255000"/>
+              </a:schemeClr>
+            </a:gs>
+          </a:gsLst>
+          <a:path path="circle">
+            <a:fillToRect l="50000" t="-80000" r="50000" b="180000"/>
+          </a:path>
+        </a:gradFill>
+        <a:gradFill rotWithShape="1">
+          <a:gsLst>
+            <a:gs pos="0">
+              <a:schemeClr val="phClr">
+                <a:tint val="80000"/>
+                <a:satMod val="300000"/>
+              </a:schemeClr>
+            </a:gs>
+            <a:gs pos="100000">
+              <a:schemeClr val="phClr">
+                <a:shade val="30000"/>
+                <a:satMod val="200000"/>
+              </a:schemeClr>
+            </a:gs>
+          </a:gsLst>
+          <a:path path="circle">
+            <a:fillToRect l="50000" t="50000" r="50000" b="50000"/>
+          </a:path>
+        </a:gradFill>
         <a:solidFill>
           <a:schemeClr val="phClr"/>
         </a:solidFill>
@@ -6228,7 +6256,6 @@
       </a:style>
     </a:lnDef>
   </a:objectDefaults>
-  <a:extraClrSchemeLst/>
   <a:extLst>
     <a:ext uri="{05A4C25C-085E-4340-85A3-A5531E510DB2}">
       <thm15:themeFamily xmlns:thm15="http://schemas.microsoft.com/office/thememl/2012/main" name="Office Theme" id="{2E142A2C-CD16-42D6-873A-C26D2A0506FA}" vid="{1BDDFF52-6CD6-40A5-AB3C-68EB2F1E4D0A}"/>

</xml_diff>